<commit_message>
feat: promote all 18 companies to 11-slide rich decks + rich new-company generator
- brands_rich.py: distinctive rich content (Lucide icons per cell, Why/What/How,
  AS-IS->확대 comparison table, 4-axis strategy, gantt roadmap) for all 18 non-flagship
  companies. All rebuilt to 11 slides, PASS.
- render_deck textfigure: native right panel (brand-colored, keyword points) when no
  hero image, so image-free decks still look complete.
- build_all: 11-slide rich make_spec; flagships kept intact (hero images preserved);
  validate uses real slide count.
- new_company.py: now scaffolds the full 11-slide rich layout (icons/table/gantt/
  numbered/textfigure) so future companies match depth out of the box.

Co-Authored-By: Claude Opus 4.8 <noreply@anthropic.com>
</commit_message>
<xml_diff>
--- a/skills/deck-celltrion/examples/celltrion-6p.pptx
+++ b/skills/deck-celltrion/examples/celltrion-6p.pptx
@@ -11,6 +11,11 @@
     <p:sldId id="259" r:id="rId10"/>
     <p:sldId id="260" r:id="rId11"/>
     <p:sldId id="261" r:id="rId12"/>
+    <p:sldId id="262" r:id="rId13"/>
+    <p:sldId id="263" r:id="rId14"/>
+    <p:sldId id="264" r:id="rId15"/>
+    <p:sldId id="265" r:id="rId16"/>
+    <p:sldId id="266" r:id="rId17"/>
   </p:sldIdLst>
   <p:sldSz cx="12191695" cy="6858000" type="screen4x3"/>
   <p:notesSz cx="6858000" cy="9144000"/>
@@ -3269,6 +3274,514 @@
 </p:sld>
 </file>
 
+<file path=ppt/slides/slide10.xml><?xml version="1.0" encoding="utf-8"?>
+<p:sld xmlns:a="http://schemas.openxmlformats.org/drawingml/2006/main" xmlns:p="http://schemas.openxmlformats.org/presentationml/2006/main" xmlns:r="http://schemas.openxmlformats.org/officeDocument/2006/relationships">
+  <p:cSld>
+    <p:bg>
+      <p:bgPr>
+        <a:solidFill>
+          <a:srgbClr val="FFFFFF"/>
+        </a:solidFill>
+        <a:effectLst/>
+      </p:bgPr>
+    </p:bg>
+    <p:spTree>
+      <p:nvGrpSpPr>
+        <p:cNvPr id="1" name=""/>
+        <p:cNvGrpSpPr/>
+        <p:nvPr/>
+      </p:nvGrpSpPr>
+      <p:grpSpPr/>
+      <p:sp>
+        <p:nvSpPr>
+          <p:cNvPr id="2" name="TextBox 1"/>
+          <p:cNvSpPr txBox="1"/>
+          <p:nvPr/>
+        </p:nvSpPr>
+        <p:spPr>
+          <a:xfrm>
+            <a:off x="566928" y="402336"/>
+            <a:ext cx="8686800" cy="292608"/>
+          </a:xfrm>
+          <a:prstGeom prst="rect">
+            <a:avLst/>
+          </a:prstGeom>
+          <a:noFill/>
+        </p:spPr>
+        <p:txBody>
+          <a:bodyPr wrap="square" anchor="t" lIns="0" rIns="0" tIns="0" bIns="0">
+            <a:spAutoFit/>
+          </a:bodyPr>
+          <a:lstStyle/>
+          <a:p>
+            <a:pPr algn="l">
+              <a:lnSpc>
+                <a:spcPct val="115000"/>
+              </a:lnSpc>
+              <a:spcBef>
+                <a:spcPts val="0"/>
+              </a:spcBef>
+              <a:spcAft>
+                <a:spcPts val="0"/>
+              </a:spcAft>
+            </a:pPr>
+            <a:r>
+              <a:rPr sz="1100" b="1" spc="120">
+                <a:solidFill>
+                  <a:srgbClr val="2E7D32"/>
+                </a:solidFill>
+                <a:latin typeface="Pretendard"/>
+                <a:ea typeface="Pretendard"/>
+              </a:rPr>
+              <a:t>04 · 성장 로드맵</a:t>
+            </a:r>
+          </a:p>
+        </p:txBody>
+      </p:sp>
+      <p:sp>
+        <p:nvSpPr>
+          <p:cNvPr id="3" name="TextBox 2"/>
+          <p:cNvSpPr txBox="1"/>
+          <p:nvPr/>
+        </p:nvSpPr>
+        <p:spPr>
+          <a:xfrm>
+            <a:off x="566928" y="841248"/>
+            <a:ext cx="11064240" cy="914400"/>
+          </a:xfrm>
+          <a:prstGeom prst="rect">
+            <a:avLst/>
+          </a:prstGeom>
+          <a:noFill/>
+        </p:spPr>
+        <p:txBody>
+          <a:bodyPr wrap="square" anchor="t" lIns="0" rIns="0" tIns="0" bIns="0">
+            <a:spAutoFit/>
+          </a:bodyPr>
+          <a:lstStyle/>
+          <a:p>
+            <a:pPr algn="l">
+              <a:lnSpc>
+                <a:spcPct val="115000"/>
+              </a:lnSpc>
+              <a:spcBef>
+                <a:spcPts val="0"/>
+              </a:spcBef>
+              <a:spcAft>
+                <a:spcPts val="0"/>
+              </a:spcAft>
+            </a:pPr>
+            <a:r>
+              <a:rPr sz="2500" b="1">
+                <a:solidFill>
+                  <a:srgbClr val="1A1A1A"/>
+                </a:solidFill>
+                <a:latin typeface="Pretendard"/>
+                <a:ea typeface="Pretendard"/>
+              </a:rPr>
+              <a:t>성장 지표</a:t>
+            </a:r>
+          </a:p>
+        </p:txBody>
+      </p:sp>
+      <p:sp>
+        <p:nvSpPr>
+          <p:cNvPr id="4" name="TextBox 3"/>
+          <p:cNvSpPr txBox="1"/>
+          <p:nvPr/>
+        </p:nvSpPr>
+        <p:spPr>
+          <a:xfrm>
+            <a:off x="566928" y="1627632"/>
+            <a:ext cx="11064240" cy="548640"/>
+          </a:xfrm>
+          <a:prstGeom prst="rect">
+            <a:avLst/>
+          </a:prstGeom>
+          <a:noFill/>
+        </p:spPr>
+        <p:txBody>
+          <a:bodyPr wrap="square" anchor="t" lIns="0" rIns="0" tIns="0" bIns="0">
+            <a:spAutoFit/>
+          </a:bodyPr>
+          <a:lstStyle/>
+          <a:p>
+            <a:pPr algn="l">
+              <a:lnSpc>
+                <a:spcPct val="115000"/>
+              </a:lnSpc>
+              <a:spcBef>
+                <a:spcPts val="0"/>
+              </a:spcBef>
+              <a:spcAft>
+                <a:spcPts val="0"/>
+              </a:spcAft>
+            </a:pPr>
+            <a:r>
+              <a:rPr sz="1400" b="0">
+                <a:solidFill>
+                  <a:srgbClr val="4A4A4A"/>
+                </a:solidFill>
+                <a:latin typeface="Pretendard"/>
+                <a:ea typeface="Pretendard"/>
+              </a:rPr>
+              <a:t>바이오시밀러와 신약으로 여는 글로벌 헬스케어</a:t>
+            </a:r>
+          </a:p>
+        </p:txBody>
+      </p:sp>
+      <p:sp>
+        <p:nvSpPr>
+          <p:cNvPr id="5" name="Rectangle 4"/>
+          <p:cNvSpPr/>
+          <p:nvPr/>
+        </p:nvSpPr>
+        <p:spPr>
+          <a:xfrm>
+            <a:off x="566928" y="2194560"/>
+            <a:ext cx="1005840" cy="41148"/>
+          </a:xfrm>
+          <a:prstGeom prst="rect">
+            <a:avLst/>
+          </a:prstGeom>
+          <a:solidFill>
+            <a:srgbClr val="50B848"/>
+          </a:solidFill>
+          <a:ln>
+            <a:noFill/>
+          </a:ln>
+          <a:effectLst/>
+        </p:spPr>
+        <p:style>
+          <a:lnRef idx="1">
+            <a:schemeClr val="accent1"/>
+          </a:lnRef>
+          <a:fillRef idx="3">
+            <a:schemeClr val="accent1"/>
+          </a:fillRef>
+          <a:effectRef idx="2">
+            <a:schemeClr val="accent1"/>
+          </a:effectRef>
+          <a:fontRef idx="minor">
+            <a:schemeClr val="lt1"/>
+          </a:fontRef>
+        </p:style>
+        <p:txBody>
+          <a:bodyPr rtlCol="0" anchor="ctr"/>
+          <a:lstStyle/>
+          <a:p>
+            <a:pPr algn="ctr"/>
+          </a:p>
+        </p:txBody>
+      </p:sp>
+      <p:sp>
+        <p:nvSpPr>
+          <p:cNvPr id="6" name="Rectangle 5"/>
+          <p:cNvSpPr/>
+          <p:nvPr/>
+        </p:nvSpPr>
+        <p:spPr>
+          <a:xfrm>
+            <a:off x="1572768" y="2211019"/>
+            <a:ext cx="10058400" cy="10972"/>
+          </a:xfrm>
+          <a:prstGeom prst="rect">
+            <a:avLst/>
+          </a:prstGeom>
+          <a:solidFill>
+            <a:srgbClr val="E1E3E8"/>
+          </a:solidFill>
+          <a:ln>
+            <a:noFill/>
+          </a:ln>
+          <a:effectLst/>
+        </p:spPr>
+        <p:style>
+          <a:lnRef idx="1">
+            <a:schemeClr val="accent1"/>
+          </a:lnRef>
+          <a:fillRef idx="3">
+            <a:schemeClr val="accent1"/>
+          </a:fillRef>
+          <a:effectRef idx="2">
+            <a:schemeClr val="accent1"/>
+          </a:effectRef>
+          <a:fontRef idx="minor">
+            <a:schemeClr val="lt1"/>
+          </a:fontRef>
+        </p:style>
+        <p:txBody>
+          <a:bodyPr rtlCol="0" anchor="ctr"/>
+          <a:lstStyle/>
+          <a:p>
+            <a:pPr algn="ctr"/>
+          </a:p>
+        </p:txBody>
+      </p:sp>
+      <p:pic>
+        <p:nvPicPr>
+          <p:cNvPr id="7" name="Picture 6" descr="kpi_2.png"/>
+          <p:cNvPicPr>
+            <a:picLocks noChangeAspect="1"/>
+          </p:cNvPicPr>
+          <p:nvPr/>
+        </p:nvPicPr>
+        <p:blipFill>
+          <a:blip r:embed="rId2"/>
+          <a:stretch>
+            <a:fillRect/>
+          </a:stretch>
+        </p:blipFill>
+        <p:spPr>
+          <a:xfrm>
+            <a:off x="1398696" y="2514600"/>
+            <a:ext cx="9400703" cy="3566160"/>
+          </a:xfrm>
+          <a:prstGeom prst="rect">
+            <a:avLst/>
+          </a:prstGeom>
+        </p:spPr>
+      </p:pic>
+      <p:sp>
+        <p:nvSpPr>
+          <p:cNvPr id="8" name="TextBox 7"/>
+          <p:cNvSpPr txBox="1"/>
+          <p:nvPr/>
+        </p:nvSpPr>
+        <p:spPr>
+          <a:xfrm>
+            <a:off x="566928" y="6172200"/>
+            <a:ext cx="11064240" cy="365760"/>
+          </a:xfrm>
+          <a:prstGeom prst="rect">
+            <a:avLst/>
+          </a:prstGeom>
+          <a:noFill/>
+        </p:spPr>
+        <p:txBody>
+          <a:bodyPr wrap="square" anchor="t" lIns="0" rIns="0" tIns="0" bIns="0">
+            <a:spAutoFit/>
+          </a:bodyPr>
+          <a:lstStyle/>
+          <a:p>
+            <a:pPr algn="l">
+              <a:lnSpc>
+                <a:spcPct val="115000"/>
+              </a:lnSpc>
+              <a:spcBef>
+                <a:spcPts val="0"/>
+              </a:spcBef>
+              <a:spcAft>
+                <a:spcPts val="0"/>
+              </a:spcAft>
+            </a:pPr>
+            <a:r>
+              <a:rPr sz="1050" b="0">
+                <a:solidFill>
+                  <a:srgbClr val="8A8A8A"/>
+                </a:solidFill>
+                <a:latin typeface="Pretendard"/>
+                <a:ea typeface="Pretendard"/>
+              </a:rPr>
+              <a:t>※ 수치는 브랜드 테마 디자인 예시입니다 (illustrative placeholder values)</a:t>
+            </a:r>
+          </a:p>
+        </p:txBody>
+      </p:sp>
+    </p:spTree>
+  </p:cSld>
+  <p:clrMapOvr>
+    <a:masterClrMapping/>
+  </p:clrMapOvr>
+</p:sld>
+</file>
+
+<file path=ppt/slides/slide11.xml><?xml version="1.0" encoding="utf-8"?>
+<p:sld xmlns:a="http://schemas.openxmlformats.org/drawingml/2006/main" xmlns:p="http://schemas.openxmlformats.org/presentationml/2006/main" xmlns:r="http://schemas.openxmlformats.org/officeDocument/2006/relationships">
+  <p:cSld>
+    <p:bg>
+      <p:bgPr>
+        <a:solidFill>
+          <a:srgbClr val="00552D"/>
+        </a:solidFill>
+        <a:effectLst/>
+      </p:bgPr>
+    </p:bg>
+    <p:spTree>
+      <p:nvGrpSpPr>
+        <p:cNvPr id="1" name=""/>
+        <p:cNvGrpSpPr/>
+        <p:nvPr/>
+      </p:nvGrpSpPr>
+      <p:grpSpPr/>
+      <p:sp>
+        <p:nvSpPr>
+          <p:cNvPr id="2" name="Rectangle 1"/>
+          <p:cNvSpPr/>
+          <p:nvPr/>
+        </p:nvSpPr>
+        <p:spPr>
+          <a:xfrm>
+            <a:off x="640080" y="2651760"/>
+            <a:ext cx="822960" cy="109728"/>
+          </a:xfrm>
+          <a:prstGeom prst="rect">
+            <a:avLst/>
+          </a:prstGeom>
+          <a:solidFill>
+            <a:srgbClr val="50B848"/>
+          </a:solidFill>
+          <a:ln>
+            <a:noFill/>
+          </a:ln>
+          <a:effectLst/>
+        </p:spPr>
+        <p:style>
+          <a:lnRef idx="1">
+            <a:schemeClr val="accent1"/>
+          </a:lnRef>
+          <a:fillRef idx="3">
+            <a:schemeClr val="accent1"/>
+          </a:fillRef>
+          <a:effectRef idx="2">
+            <a:schemeClr val="accent1"/>
+          </a:effectRef>
+          <a:fontRef idx="minor">
+            <a:schemeClr val="lt1"/>
+          </a:fontRef>
+        </p:style>
+        <p:txBody>
+          <a:bodyPr rtlCol="0" anchor="ctr"/>
+          <a:lstStyle/>
+          <a:p>
+            <a:pPr algn="ctr"/>
+          </a:p>
+        </p:txBody>
+      </p:sp>
+      <p:sp>
+        <p:nvSpPr>
+          <p:cNvPr id="3" name="TextBox 2"/>
+          <p:cNvSpPr txBox="1"/>
+          <p:nvPr/>
+        </p:nvSpPr>
+        <p:spPr>
+          <a:xfrm>
+            <a:off x="566928" y="2880360"/>
+            <a:ext cx="11064240" cy="2377440"/>
+          </a:xfrm>
+          <a:prstGeom prst="rect">
+            <a:avLst/>
+          </a:prstGeom>
+          <a:noFill/>
+        </p:spPr>
+        <p:txBody>
+          <a:bodyPr wrap="square" anchor="t" lIns="0" rIns="0" tIns="0" bIns="0">
+            <a:spAutoFit/>
+          </a:bodyPr>
+          <a:lstStyle/>
+          <a:p>
+            <a:pPr algn="l">
+              <a:lnSpc>
+                <a:spcPct val="115000"/>
+              </a:lnSpc>
+              <a:spcBef>
+                <a:spcPts val="0"/>
+              </a:spcBef>
+              <a:spcAft>
+                <a:spcPts val="0"/>
+              </a:spcAft>
+            </a:pPr>
+            <a:r>
+              <a:rPr sz="4000" b="1">
+                <a:solidFill>
+                  <a:srgbClr val="FFFFFF"/>
+                </a:solidFill>
+                <a:latin typeface="Pretendard"/>
+                <a:ea typeface="Pretendard"/>
+              </a:rPr>
+              <a:t>건강한 미래를
+함께 만듭니다</a:t>
+            </a:r>
+          </a:p>
+          <a:p>
+            <a:pPr algn="l">
+              <a:lnSpc>
+                <a:spcPct val="135000"/>
+              </a:lnSpc>
+              <a:spcBef>
+                <a:spcPts val="1200"/>
+              </a:spcBef>
+              <a:spcAft>
+                <a:spcPts val="0"/>
+              </a:spcAft>
+            </a:pPr>
+            <a:r>
+              <a:rPr sz="1500" b="0">
+                <a:solidFill>
+                  <a:srgbClr val="FFFFFF"/>
+                </a:solidFill>
+                <a:latin typeface="Pretendard"/>
+                <a:ea typeface="Pretendard"/>
+              </a:rPr>
+              <a:t>Celltrion</a:t>
+            </a:r>
+          </a:p>
+        </p:txBody>
+      </p:sp>
+      <p:sp>
+        <p:nvSpPr>
+          <p:cNvPr id="4" name="TextBox 3"/>
+          <p:cNvSpPr txBox="1"/>
+          <p:nvPr/>
+        </p:nvSpPr>
+        <p:spPr>
+          <a:xfrm>
+            <a:off x="566928" y="6035040"/>
+            <a:ext cx="11064240" cy="365760"/>
+          </a:xfrm>
+          <a:prstGeom prst="rect">
+            <a:avLst/>
+          </a:prstGeom>
+          <a:noFill/>
+        </p:spPr>
+        <p:txBody>
+          <a:bodyPr wrap="square" anchor="t" lIns="0" rIns="0" tIns="0" bIns="0">
+            <a:spAutoFit/>
+          </a:bodyPr>
+          <a:lstStyle/>
+          <a:p>
+            <a:pPr algn="l">
+              <a:lnSpc>
+                <a:spcPct val="115000"/>
+              </a:lnSpc>
+              <a:spcBef>
+                <a:spcPts val="0"/>
+              </a:spcBef>
+              <a:spcAft>
+                <a:spcPts val="0"/>
+              </a:spcAft>
+            </a:pPr>
+            <a:r>
+              <a:rPr sz="1100" b="0">
+                <a:solidFill>
+                  <a:srgbClr val="FFFFFF"/>
+                </a:solidFill>
+                <a:latin typeface="Pretendard"/>
+                <a:ea typeface="Pretendard"/>
+              </a:rPr>
+              <a:t>brand-inspired sample deck · 상표는 셀트리온 (Celltrion, Inc.)의 자산입니다</a:t>
+            </a:r>
+          </a:p>
+        </p:txBody>
+      </p:sp>
+    </p:spTree>
+  </p:cSld>
+  <p:clrMapOvr>
+    <a:masterClrMapping/>
+  </p:clrMapOvr>
+</p:sld>
+</file>
+
 <file path=ppt/slides/slide2.xml><?xml version="1.0" encoding="utf-8"?>
 <p:sld xmlns:a="http://schemas.openxmlformats.org/drawingml/2006/main" xmlns:p="http://schemas.openxmlformats.org/presentationml/2006/main" xmlns:r="http://schemas.openxmlformats.org/officeDocument/2006/relationships">
   <p:cSld>
@@ -3295,8 +3808,8 @@
         </p:nvSpPr>
         <p:spPr>
           <a:xfrm>
-            <a:off x="566928" y="841248"/>
-            <a:ext cx="11064240" cy="914400"/>
+            <a:off x="566928" y="402336"/>
+            <a:ext cx="8686800" cy="292608"/>
           </a:xfrm>
           <a:prstGeom prst="rect">
             <a:avLst/>
@@ -3321,6 +3834,52 @@
               </a:spcAft>
             </a:pPr>
             <a:r>
+              <a:rPr sz="1100" b="1" spc="120">
+                <a:solidFill>
+                  <a:srgbClr val="2E7D32"/>
+                </a:solidFill>
+                <a:latin typeface="Pretendard"/>
+                <a:ea typeface="Pretendard"/>
+              </a:rPr>
+              <a:t>CELLTRION</a:t>
+            </a:r>
+          </a:p>
+        </p:txBody>
+      </p:sp>
+      <p:sp>
+        <p:nvSpPr>
+          <p:cNvPr id="3" name="TextBox 2"/>
+          <p:cNvSpPr txBox="1"/>
+          <p:nvPr/>
+        </p:nvSpPr>
+        <p:spPr>
+          <a:xfrm>
+            <a:off x="566928" y="841248"/>
+            <a:ext cx="11064240" cy="914400"/>
+          </a:xfrm>
+          <a:prstGeom prst="rect">
+            <a:avLst/>
+          </a:prstGeom>
+          <a:noFill/>
+        </p:spPr>
+        <p:txBody>
+          <a:bodyPr wrap="square" anchor="t" lIns="0" rIns="0" tIns="0" bIns="0">
+            <a:spAutoFit/>
+          </a:bodyPr>
+          <a:lstStyle/>
+          <a:p>
+            <a:pPr algn="l">
+              <a:lnSpc>
+                <a:spcPct val="115000"/>
+              </a:lnSpc>
+              <a:spcBef>
+                <a:spcPts val="0"/>
+              </a:spcBef>
+              <a:spcAft>
+                <a:spcPts val="0"/>
+              </a:spcAft>
+            </a:pPr>
+            <a:r>
               <a:rPr sz="2500" b="1">
                 <a:solidFill>
                   <a:srgbClr val="1A1A1A"/>
@@ -3335,7 +3894,7 @@
       </p:sp>
       <p:sp>
         <p:nvSpPr>
-          <p:cNvPr id="3" name="Rectangle 2"/>
+          <p:cNvPr id="4" name="Rectangle 3"/>
           <p:cNvSpPr/>
           <p:nvPr/>
         </p:nvSpPr>
@@ -3379,7 +3938,7 @@
       </p:sp>
       <p:sp>
         <p:nvSpPr>
-          <p:cNvPr id="4" name="Rectangle 3"/>
+          <p:cNvPr id="5" name="Rectangle 4"/>
           <p:cNvSpPr/>
           <p:nvPr/>
         </p:nvSpPr>
@@ -3423,7 +3982,7 @@
       </p:sp>
       <p:sp>
         <p:nvSpPr>
-          <p:cNvPr id="5" name="Rectangle 4"/>
+          <p:cNvPr id="6" name="Rectangle 5"/>
           <p:cNvSpPr/>
           <p:nvPr/>
         </p:nvSpPr>
@@ -3467,7 +4026,7 @@
       </p:sp>
       <p:sp>
         <p:nvSpPr>
-          <p:cNvPr id="6" name="TextBox 5"/>
+          <p:cNvPr id="7" name="TextBox 6"/>
           <p:cNvSpPr txBox="1"/>
           <p:nvPr/>
         </p:nvSpPr>
@@ -3513,7 +4072,7 @@
       </p:sp>
       <p:sp>
         <p:nvSpPr>
-          <p:cNvPr id="7" name="TextBox 6"/>
+          <p:cNvPr id="8" name="TextBox 7"/>
           <p:cNvSpPr txBox="1"/>
           <p:nvPr/>
         </p:nvSpPr>
@@ -3552,14 +4111,14 @@
                 <a:latin typeface="Pretendard"/>
                 <a:ea typeface="Pretendard"/>
               </a:rPr>
-              <a:t>회사 개요</a:t>
-            </a:r>
-          </a:p>
-        </p:txBody>
-      </p:sp>
-      <p:sp>
-        <p:nvSpPr>
-          <p:cNvPr id="8" name="TextBox 7"/>
+              <a:t>사업 개요</a:t>
+            </a:r>
+          </a:p>
+        </p:txBody>
+      </p:sp>
+      <p:sp>
+        <p:nvSpPr>
+          <p:cNvPr id="9" name="TextBox 8"/>
           <p:cNvSpPr txBox="1"/>
           <p:nvPr/>
         </p:nvSpPr>
@@ -3605,13 +4164,13 @@
       </p:sp>
       <p:sp>
         <p:nvSpPr>
-          <p:cNvPr id="9" name="Rectangle 8"/>
+          <p:cNvPr id="10" name="Rectangle 9"/>
           <p:cNvSpPr/>
           <p:nvPr/>
         </p:nvSpPr>
         <p:spPr>
           <a:xfrm>
-            <a:off x="566928" y="3803903"/>
+            <a:off x="566928" y="3552444"/>
             <a:ext cx="10881360" cy="9144"/>
           </a:xfrm>
           <a:prstGeom prst="rect">
@@ -3649,13 +4208,13 @@
       </p:sp>
       <p:sp>
         <p:nvSpPr>
-          <p:cNvPr id="10" name="TextBox 9"/>
+          <p:cNvPr id="11" name="TextBox 10"/>
           <p:cNvSpPr txBox="1"/>
           <p:nvPr/>
         </p:nvSpPr>
         <p:spPr>
           <a:xfrm>
-            <a:off x="566928" y="3749039"/>
+            <a:off x="566928" y="3497580"/>
             <a:ext cx="822960" cy="457200"/>
           </a:xfrm>
           <a:prstGeom prst="rect">
@@ -3695,13 +4254,13 @@
       </p:sp>
       <p:sp>
         <p:nvSpPr>
-          <p:cNvPr id="11" name="TextBox 10"/>
+          <p:cNvPr id="12" name="TextBox 11"/>
           <p:cNvSpPr txBox="1"/>
           <p:nvPr/>
         </p:nvSpPr>
         <p:spPr>
           <a:xfrm>
-            <a:off x="1554480" y="3749039"/>
+            <a:off x="1554480" y="3497580"/>
             <a:ext cx="8686800" cy="457200"/>
           </a:xfrm>
           <a:prstGeom prst="rect">
@@ -3741,13 +4300,13 @@
       </p:sp>
       <p:sp>
         <p:nvSpPr>
-          <p:cNvPr id="12" name="TextBox 11"/>
+          <p:cNvPr id="13" name="TextBox 12"/>
           <p:cNvSpPr txBox="1"/>
           <p:nvPr/>
         </p:nvSpPr>
         <p:spPr>
           <a:xfrm>
-            <a:off x="10698480" y="3749039"/>
+            <a:off x="10698480" y="3497580"/>
             <a:ext cx="822960" cy="457200"/>
           </a:xfrm>
           <a:prstGeom prst="rect">
@@ -3780,20 +4339,20 @@
                 <a:latin typeface="Pretendard"/>
                 <a:ea typeface="Pretendard"/>
               </a:rPr>
-              <a:t>04</a:t>
-            </a:r>
-          </a:p>
-        </p:txBody>
-      </p:sp>
-      <p:sp>
-        <p:nvSpPr>
-          <p:cNvPr id="13" name="Rectangle 12"/>
+              <a:t>05</a:t>
+            </a:r>
+          </a:p>
+        </p:txBody>
+      </p:sp>
+      <p:sp>
+        <p:nvSpPr>
+          <p:cNvPr id="14" name="Rectangle 13"/>
           <p:cNvSpPr/>
           <p:nvPr/>
         </p:nvSpPr>
         <p:spPr>
           <a:xfrm>
-            <a:off x="566928" y="4809743"/>
+            <a:off x="566928" y="4306824"/>
             <a:ext cx="10881360" cy="9144"/>
           </a:xfrm>
           <a:prstGeom prst="rect">
@@ -3831,13 +4390,13 @@
       </p:sp>
       <p:sp>
         <p:nvSpPr>
-          <p:cNvPr id="14" name="TextBox 13"/>
+          <p:cNvPr id="15" name="TextBox 14"/>
           <p:cNvSpPr txBox="1"/>
           <p:nvPr/>
         </p:nvSpPr>
         <p:spPr>
           <a:xfrm>
-            <a:off x="566928" y="4754879"/>
+            <a:off x="566928" y="4251960"/>
             <a:ext cx="822960" cy="457200"/>
           </a:xfrm>
           <a:prstGeom prst="rect">
@@ -3877,13 +4436,13 @@
       </p:sp>
       <p:sp>
         <p:nvSpPr>
-          <p:cNvPr id="15" name="TextBox 14"/>
+          <p:cNvPr id="16" name="TextBox 15"/>
           <p:cNvSpPr txBox="1"/>
           <p:nvPr/>
         </p:nvSpPr>
         <p:spPr>
           <a:xfrm>
-            <a:off x="1554480" y="4754879"/>
+            <a:off x="1554480" y="4251960"/>
             <a:ext cx="8686800" cy="457200"/>
           </a:xfrm>
           <a:prstGeom prst="rect">
@@ -3916,20 +4475,20 @@
                 <a:latin typeface="Pretendard"/>
                 <a:ea typeface="Pretendard"/>
               </a:rPr>
-              <a:t>성장 지표</a:t>
-            </a:r>
-          </a:p>
-        </p:txBody>
-      </p:sp>
-      <p:sp>
-        <p:nvSpPr>
-          <p:cNvPr id="16" name="TextBox 15"/>
+              <a:t>성장 전략</a:t>
+            </a:r>
+          </a:p>
+        </p:txBody>
+      </p:sp>
+      <p:sp>
+        <p:nvSpPr>
+          <p:cNvPr id="17" name="TextBox 16"/>
           <p:cNvSpPr txBox="1"/>
           <p:nvPr/>
         </p:nvSpPr>
         <p:spPr>
           <a:xfrm>
-            <a:off x="10698480" y="4754879"/>
+            <a:off x="10698480" y="4251960"/>
             <a:ext cx="822960" cy="457200"/>
           </a:xfrm>
           <a:prstGeom prst="rect">
@@ -3962,20 +4521,20 @@
                 <a:latin typeface="Pretendard"/>
                 <a:ea typeface="Pretendard"/>
               </a:rPr>
-              <a:t>05</a:t>
-            </a:r>
-          </a:p>
-        </p:txBody>
-      </p:sp>
-      <p:sp>
-        <p:nvSpPr>
-          <p:cNvPr id="17" name="Rectangle 16"/>
+              <a:t>07</a:t>
+            </a:r>
+          </a:p>
+        </p:txBody>
+      </p:sp>
+      <p:sp>
+        <p:nvSpPr>
+          <p:cNvPr id="18" name="Rectangle 17"/>
           <p:cNvSpPr/>
           <p:nvPr/>
         </p:nvSpPr>
         <p:spPr>
           <a:xfrm>
-            <a:off x="566928" y="5815583"/>
+            <a:off x="566928" y="5061203"/>
             <a:ext cx="10881360" cy="9144"/>
           </a:xfrm>
           <a:prstGeom prst="rect">
@@ -4013,13 +4572,13 @@
       </p:sp>
       <p:sp>
         <p:nvSpPr>
-          <p:cNvPr id="18" name="TextBox 17"/>
+          <p:cNvPr id="19" name="TextBox 18"/>
           <p:cNvSpPr txBox="1"/>
           <p:nvPr/>
         </p:nvSpPr>
         <p:spPr>
           <a:xfrm>
-            <a:off x="566928" y="5760720"/>
+            <a:off x="566928" y="5006340"/>
             <a:ext cx="822960" cy="457200"/>
           </a:xfrm>
           <a:prstGeom prst="rect">
@@ -4059,13 +4618,13 @@
       </p:sp>
       <p:sp>
         <p:nvSpPr>
-          <p:cNvPr id="19" name="TextBox 18"/>
+          <p:cNvPr id="20" name="TextBox 19"/>
           <p:cNvSpPr txBox="1"/>
           <p:nvPr/>
         </p:nvSpPr>
         <p:spPr>
           <a:xfrm>
-            <a:off x="1554480" y="5760720"/>
+            <a:off x="1554480" y="5006340"/>
             <a:ext cx="8686800" cy="457200"/>
           </a:xfrm>
           <a:prstGeom prst="rect">
@@ -4098,20 +4657,20 @@
                 <a:latin typeface="Pretendard"/>
                 <a:ea typeface="Pretendard"/>
               </a:rPr>
-              <a:t>미래 비전</a:t>
-            </a:r>
-          </a:p>
-        </p:txBody>
-      </p:sp>
-      <p:sp>
-        <p:nvSpPr>
-          <p:cNvPr id="20" name="TextBox 19"/>
+              <a:t>성장 로드맵</a:t>
+            </a:r>
+          </a:p>
+        </p:txBody>
+      </p:sp>
+      <p:sp>
+        <p:nvSpPr>
+          <p:cNvPr id="21" name="TextBox 20"/>
           <p:cNvSpPr txBox="1"/>
           <p:nvPr/>
         </p:nvSpPr>
         <p:spPr>
           <a:xfrm>
-            <a:off x="10698480" y="5760720"/>
+            <a:off x="10698480" y="5006340"/>
             <a:ext cx="822960" cy="457200"/>
           </a:xfrm>
           <a:prstGeom prst="rect">
@@ -4144,7 +4703,189 @@
                 <a:latin typeface="Pretendard"/>
                 <a:ea typeface="Pretendard"/>
               </a:rPr>
-              <a:t>06</a:t>
+              <a:t>09</a:t>
+            </a:r>
+          </a:p>
+        </p:txBody>
+      </p:sp>
+      <p:sp>
+        <p:nvSpPr>
+          <p:cNvPr id="22" name="Rectangle 21"/>
+          <p:cNvSpPr/>
+          <p:nvPr/>
+        </p:nvSpPr>
+        <p:spPr>
+          <a:xfrm>
+            <a:off x="566928" y="5815583"/>
+            <a:ext cx="10881360" cy="9144"/>
+          </a:xfrm>
+          <a:prstGeom prst="rect">
+            <a:avLst/>
+          </a:prstGeom>
+          <a:solidFill>
+            <a:srgbClr val="E1E3E8"/>
+          </a:solidFill>
+          <a:ln>
+            <a:noFill/>
+          </a:ln>
+          <a:effectLst/>
+        </p:spPr>
+        <p:style>
+          <a:lnRef idx="1">
+            <a:schemeClr val="accent1"/>
+          </a:lnRef>
+          <a:fillRef idx="3">
+            <a:schemeClr val="accent1"/>
+          </a:fillRef>
+          <a:effectRef idx="2">
+            <a:schemeClr val="accent1"/>
+          </a:effectRef>
+          <a:fontRef idx="minor">
+            <a:schemeClr val="lt1"/>
+          </a:fontRef>
+        </p:style>
+        <p:txBody>
+          <a:bodyPr rtlCol="0" anchor="ctr"/>
+          <a:lstStyle/>
+          <a:p>
+            <a:pPr algn="ctr"/>
+          </a:p>
+        </p:txBody>
+      </p:sp>
+      <p:sp>
+        <p:nvSpPr>
+          <p:cNvPr id="23" name="TextBox 22"/>
+          <p:cNvSpPr txBox="1"/>
+          <p:nvPr/>
+        </p:nvSpPr>
+        <p:spPr>
+          <a:xfrm>
+            <a:off x="566928" y="5760720"/>
+            <a:ext cx="822960" cy="457200"/>
+          </a:xfrm>
+          <a:prstGeom prst="rect">
+            <a:avLst/>
+          </a:prstGeom>
+          <a:noFill/>
+        </p:spPr>
+        <p:txBody>
+          <a:bodyPr wrap="square" anchor="t" lIns="0" rIns="0" tIns="0" bIns="0">
+            <a:spAutoFit/>
+          </a:bodyPr>
+          <a:lstStyle/>
+          <a:p>
+            <a:pPr algn="l">
+              <a:lnSpc>
+                <a:spcPct val="115000"/>
+              </a:lnSpc>
+              <a:spcBef>
+                <a:spcPts val="0"/>
+              </a:spcBef>
+              <a:spcAft>
+                <a:spcPts val="0"/>
+              </a:spcAft>
+            </a:pPr>
+            <a:r>
+              <a:rPr sz="1700" b="1">
+                <a:solidFill>
+                  <a:srgbClr val="2E7D32"/>
+                </a:solidFill>
+                <a:latin typeface="Pretendard"/>
+                <a:ea typeface="Pretendard"/>
+              </a:rPr>
+              <a:t>05</a:t>
+            </a:r>
+          </a:p>
+        </p:txBody>
+      </p:sp>
+      <p:sp>
+        <p:nvSpPr>
+          <p:cNvPr id="24" name="TextBox 23"/>
+          <p:cNvSpPr txBox="1"/>
+          <p:nvPr/>
+        </p:nvSpPr>
+        <p:spPr>
+          <a:xfrm>
+            <a:off x="1554480" y="5760720"/>
+            <a:ext cx="8686800" cy="457200"/>
+          </a:xfrm>
+          <a:prstGeom prst="rect">
+            <a:avLst/>
+          </a:prstGeom>
+          <a:noFill/>
+        </p:spPr>
+        <p:txBody>
+          <a:bodyPr wrap="square" anchor="t" lIns="0" rIns="0" tIns="0" bIns="0">
+            <a:spAutoFit/>
+          </a:bodyPr>
+          <a:lstStyle/>
+          <a:p>
+            <a:pPr algn="l">
+              <a:lnSpc>
+                <a:spcPct val="115000"/>
+              </a:lnSpc>
+              <a:spcBef>
+                <a:spcPts val="0"/>
+              </a:spcBef>
+              <a:spcAft>
+                <a:spcPts val="0"/>
+              </a:spcAft>
+            </a:pPr>
+            <a:r>
+              <a:rPr sz="1600" b="1">
+                <a:solidFill>
+                  <a:srgbClr val="1A1A1A"/>
+                </a:solidFill>
+                <a:latin typeface="Pretendard"/>
+                <a:ea typeface="Pretendard"/>
+              </a:rPr>
+              <a:t>미래 비전</a:t>
+            </a:r>
+          </a:p>
+        </p:txBody>
+      </p:sp>
+      <p:sp>
+        <p:nvSpPr>
+          <p:cNvPr id="25" name="TextBox 24"/>
+          <p:cNvSpPr txBox="1"/>
+          <p:nvPr/>
+        </p:nvSpPr>
+        <p:spPr>
+          <a:xfrm>
+            <a:off x="10698480" y="5760720"/>
+            <a:ext cx="822960" cy="457200"/>
+          </a:xfrm>
+          <a:prstGeom prst="rect">
+            <a:avLst/>
+          </a:prstGeom>
+          <a:noFill/>
+        </p:spPr>
+        <p:txBody>
+          <a:bodyPr wrap="square" anchor="t" lIns="0" rIns="0" tIns="0" bIns="0">
+            <a:spAutoFit/>
+          </a:bodyPr>
+          <a:lstStyle/>
+          <a:p>
+            <a:pPr algn="r">
+              <a:lnSpc>
+                <a:spcPct val="115000"/>
+              </a:lnSpc>
+              <a:spcBef>
+                <a:spcPts val="0"/>
+              </a:spcBef>
+              <a:spcAft>
+                <a:spcPts val="0"/>
+              </a:spcAft>
+            </a:pPr>
+            <a:r>
+              <a:rPr sz="1300" b="0">
+                <a:solidFill>
+                  <a:srgbClr val="8A8A8A"/>
+                </a:solidFill>
+                <a:latin typeface="Pretendard"/>
+                <a:ea typeface="Pretendard"/>
+              </a:rPr>
+              <a:t>11</a:t>
             </a:r>
           </a:p>
         </p:txBody>
@@ -4253,7 +4994,7 @@
               </a:spcAft>
             </a:pPr>
             <a:r>
-              <a:rPr sz="5600" b="1">
+              <a:rPr sz="6000" b="1">
                 <a:solidFill>
                   <a:srgbClr val="FFFFFF"/>
                 </a:solidFill>
@@ -4283,7 +5024,7 @@
                 <a:latin typeface="Pretendard"/>
                 <a:ea typeface="Pretendard"/>
               </a:rPr>
-              <a:t>핵심 사업 영역</a:t>
+              <a:t>사업 개요</a:t>
             </a:r>
           </a:p>
           <a:p>
@@ -4378,7 +5119,7 @@
                 <a:latin typeface="Pretendard"/>
                 <a:ea typeface="Pretendard"/>
               </a:rPr>
-              <a:t>BUSINESS PORTFOLIO</a:t>
+              <a:t>01 · 사업 개요</a:t>
             </a:r>
           </a:p>
         </p:txBody>
@@ -4424,7 +5165,7 @@
                 <a:latin typeface="Pretendard"/>
                 <a:ea typeface="Pretendard"/>
               </a:rPr>
-              <a:t>핵심 사업 영역</a:t>
+              <a:t>셀트리온가 그리는 미래</a:t>
             </a:r>
           </a:p>
         </p:txBody>
@@ -4437,7 +5178,7 @@
         </p:nvSpPr>
         <p:spPr>
           <a:xfrm>
-            <a:off x="566928" y="1609344"/>
+            <a:off x="566928" y="1627632"/>
             <a:ext cx="11064240" cy="548640"/>
           </a:xfrm>
           <a:prstGeom prst="rect">
@@ -4463,14 +5204,14 @@
               </a:spcAft>
             </a:pPr>
             <a:r>
-              <a:rPr sz="1350" b="0">
+              <a:rPr sz="1400" b="0">
                 <a:solidFill>
                   <a:srgbClr val="4A4A4A"/>
                 </a:solidFill>
                 <a:latin typeface="Pretendard"/>
                 <a:ea typeface="Pretendard"/>
               </a:rPr>
-              <a:t>바이오시밀러를 넘어 신약으로</a:t>
+              <a:t>바이오시밀러와 신약으로 여는 글로벌 헬스케어</a:t>
             </a:r>
           </a:p>
         </p:txBody>
@@ -4565,20 +5306,296 @@
       </p:sp>
       <p:sp>
         <p:nvSpPr>
-          <p:cNvPr id="7" name="Rectangle 6"/>
+          <p:cNvPr id="7" name="TextBox 6"/>
+          <p:cNvSpPr txBox="1"/>
+          <p:nvPr/>
+        </p:nvSpPr>
+        <p:spPr>
+          <a:xfrm>
+            <a:off x="566928" y="2697480"/>
+            <a:ext cx="5120640" cy="384048"/>
+          </a:xfrm>
+          <a:prstGeom prst="rect">
+            <a:avLst/>
+          </a:prstGeom>
+          <a:noFill/>
+        </p:spPr>
+        <p:txBody>
+          <a:bodyPr wrap="square" anchor="t" lIns="0" rIns="0" tIns="0" bIns="0">
+            <a:spAutoFit/>
+          </a:bodyPr>
+          <a:lstStyle/>
+          <a:p>
+            <a:pPr algn="l">
+              <a:lnSpc>
+                <a:spcPct val="115000"/>
+              </a:lnSpc>
+              <a:spcBef>
+                <a:spcPts val="0"/>
+              </a:spcBef>
+              <a:spcAft>
+                <a:spcPts val="0"/>
+              </a:spcAft>
+            </a:pPr>
+            <a:r>
+              <a:rPr sz="1500" b="1">
+                <a:solidFill>
+                  <a:srgbClr val="1A1A1A"/>
+                </a:solidFill>
+                <a:latin typeface="Pretendard"/>
+                <a:ea typeface="Pretendard"/>
+              </a:rPr>
+              <a:t>Why · 시장의 변화</a:t>
+            </a:r>
+          </a:p>
+        </p:txBody>
+      </p:sp>
+      <p:sp>
+        <p:nvSpPr>
+          <p:cNvPr id="8" name="TextBox 7"/>
+          <p:cNvSpPr txBox="1"/>
+          <p:nvPr/>
+        </p:nvSpPr>
+        <p:spPr>
+          <a:xfrm>
+            <a:off x="566928" y="3099816"/>
+            <a:ext cx="5120640" cy="685800"/>
+          </a:xfrm>
+          <a:prstGeom prst="rect">
+            <a:avLst/>
+          </a:prstGeom>
+          <a:noFill/>
+        </p:spPr>
+        <p:txBody>
+          <a:bodyPr wrap="square" anchor="t" lIns="0" rIns="0" tIns="0" bIns="0">
+            <a:spAutoFit/>
+          </a:bodyPr>
+          <a:lstStyle/>
+          <a:p>
+            <a:pPr algn="l">
+              <a:lnSpc>
+                <a:spcPct val="140000"/>
+              </a:lnSpc>
+              <a:spcBef>
+                <a:spcPts val="0"/>
+              </a:spcBef>
+              <a:spcAft>
+                <a:spcPts val="0"/>
+              </a:spcAft>
+            </a:pPr>
+            <a:r>
+              <a:rPr sz="1200" b="0">
+                <a:solidFill>
+                  <a:srgbClr val="4A4A4A"/>
+                </a:solidFill>
+                <a:latin typeface="Pretendard"/>
+                <a:ea typeface="Pretendard"/>
+              </a:rPr>
+              <a:t>바이오시밀러 시장 확대와 신약 개발이 성장의 축이 되고 있습니다.</a:t>
+            </a:r>
+          </a:p>
+        </p:txBody>
+      </p:sp>
+      <p:sp>
+        <p:nvSpPr>
+          <p:cNvPr id="9" name="TextBox 8"/>
+          <p:cNvSpPr txBox="1"/>
+          <p:nvPr/>
+        </p:nvSpPr>
+        <p:spPr>
+          <a:xfrm>
+            <a:off x="566928" y="3840480"/>
+            <a:ext cx="5120640" cy="384048"/>
+          </a:xfrm>
+          <a:prstGeom prst="rect">
+            <a:avLst/>
+          </a:prstGeom>
+          <a:noFill/>
+        </p:spPr>
+        <p:txBody>
+          <a:bodyPr wrap="square" anchor="t" lIns="0" rIns="0" tIns="0" bIns="0">
+            <a:spAutoFit/>
+          </a:bodyPr>
+          <a:lstStyle/>
+          <a:p>
+            <a:pPr algn="l">
+              <a:lnSpc>
+                <a:spcPct val="115000"/>
+              </a:lnSpc>
+              <a:spcBef>
+                <a:spcPts val="0"/>
+              </a:spcBef>
+              <a:spcAft>
+                <a:spcPts val="0"/>
+              </a:spcAft>
+            </a:pPr>
+            <a:r>
+              <a:rPr sz="1500" b="1">
+                <a:solidFill>
+                  <a:srgbClr val="1A1A1A"/>
+                </a:solidFill>
+                <a:latin typeface="Pretendard"/>
+                <a:ea typeface="Pretendard"/>
+              </a:rPr>
+              <a:t>What · 사업 영역</a:t>
+            </a:r>
+          </a:p>
+        </p:txBody>
+      </p:sp>
+      <p:sp>
+        <p:nvSpPr>
+          <p:cNvPr id="10" name="TextBox 9"/>
+          <p:cNvSpPr txBox="1"/>
+          <p:nvPr/>
+        </p:nvSpPr>
+        <p:spPr>
+          <a:xfrm>
+            <a:off x="566928" y="4242816"/>
+            <a:ext cx="5120640" cy="685800"/>
+          </a:xfrm>
+          <a:prstGeom prst="rect">
+            <a:avLst/>
+          </a:prstGeom>
+          <a:noFill/>
+        </p:spPr>
+        <p:txBody>
+          <a:bodyPr wrap="square" anchor="t" lIns="0" rIns="0" tIns="0" bIns="0">
+            <a:spAutoFit/>
+          </a:bodyPr>
+          <a:lstStyle/>
+          <a:p>
+            <a:pPr algn="l">
+              <a:lnSpc>
+                <a:spcPct val="140000"/>
+              </a:lnSpc>
+              <a:spcBef>
+                <a:spcPts val="0"/>
+              </a:spcBef>
+              <a:spcAft>
+                <a:spcPts val="0"/>
+              </a:spcAft>
+            </a:pPr>
+            <a:r>
+              <a:rPr sz="1200" b="0">
+                <a:solidFill>
+                  <a:srgbClr val="4A4A4A"/>
+                </a:solidFill>
+                <a:latin typeface="Pretendard"/>
+                <a:ea typeface="Pretendard"/>
+              </a:rPr>
+              <a:t>바이오시밀러와 신약으로 여는 글로벌 헬스케어</a:t>
+            </a:r>
+          </a:p>
+        </p:txBody>
+      </p:sp>
+      <p:sp>
+        <p:nvSpPr>
+          <p:cNvPr id="11" name="TextBox 10"/>
+          <p:cNvSpPr txBox="1"/>
+          <p:nvPr/>
+        </p:nvSpPr>
+        <p:spPr>
+          <a:xfrm>
+            <a:off x="566928" y="4983480"/>
+            <a:ext cx="5120640" cy="384048"/>
+          </a:xfrm>
+          <a:prstGeom prst="rect">
+            <a:avLst/>
+          </a:prstGeom>
+          <a:noFill/>
+        </p:spPr>
+        <p:txBody>
+          <a:bodyPr wrap="square" anchor="t" lIns="0" rIns="0" tIns="0" bIns="0">
+            <a:spAutoFit/>
+          </a:bodyPr>
+          <a:lstStyle/>
+          <a:p>
+            <a:pPr algn="l">
+              <a:lnSpc>
+                <a:spcPct val="115000"/>
+              </a:lnSpc>
+              <a:spcBef>
+                <a:spcPts val="0"/>
+              </a:spcBef>
+              <a:spcAft>
+                <a:spcPts val="0"/>
+              </a:spcAft>
+            </a:pPr>
+            <a:r>
+              <a:rPr sz="1500" b="1">
+                <a:solidFill>
+                  <a:srgbClr val="1A1A1A"/>
+                </a:solidFill>
+                <a:latin typeface="Pretendard"/>
+                <a:ea typeface="Pretendard"/>
+              </a:rPr>
+              <a:t>How · 실행 전략</a:t>
+            </a:r>
+          </a:p>
+        </p:txBody>
+      </p:sp>
+      <p:sp>
+        <p:nvSpPr>
+          <p:cNvPr id="12" name="TextBox 11"/>
+          <p:cNvSpPr txBox="1"/>
+          <p:nvPr/>
+        </p:nvSpPr>
+        <p:spPr>
+          <a:xfrm>
+            <a:off x="566928" y="5385816"/>
+            <a:ext cx="5120640" cy="685800"/>
+          </a:xfrm>
+          <a:prstGeom prst="rect">
+            <a:avLst/>
+          </a:prstGeom>
+          <a:noFill/>
+        </p:spPr>
+        <p:txBody>
+          <a:bodyPr wrap="square" anchor="t" lIns="0" rIns="0" tIns="0" bIns="0">
+            <a:spAutoFit/>
+          </a:bodyPr>
+          <a:lstStyle/>
+          <a:p>
+            <a:pPr algn="l">
+              <a:lnSpc>
+                <a:spcPct val="140000"/>
+              </a:lnSpc>
+              <a:spcBef>
+                <a:spcPts val="0"/>
+              </a:spcBef>
+              <a:spcAft>
+                <a:spcPts val="0"/>
+              </a:spcAft>
+            </a:pPr>
+            <a:r>
+              <a:rPr sz="1200" b="0">
+                <a:solidFill>
+                  <a:srgbClr val="4A4A4A"/>
+                </a:solidFill>
+                <a:latin typeface="Pretendard"/>
+                <a:ea typeface="Pretendard"/>
+              </a:rPr>
+              <a:t>바이오시밀러 경쟁력 위에 신약·직판 체계를 더합니다.</a:t>
+            </a:r>
+          </a:p>
+        </p:txBody>
+      </p:sp>
+      <p:sp>
+        <p:nvSpPr>
+          <p:cNvPr id="13" name="Rectangle 12"/>
           <p:cNvSpPr/>
           <p:nvPr/>
         </p:nvSpPr>
         <p:spPr>
           <a:xfrm>
-            <a:off x="566928" y="2651760"/>
-            <a:ext cx="457200" cy="457200"/>
+            <a:off x="6355080" y="2724912"/>
+            <a:ext cx="5257800" cy="3383280"/>
           </a:xfrm>
           <a:prstGeom prst="rect">
             <a:avLst/>
           </a:prstGeom>
           <a:solidFill>
-            <a:srgbClr val="50B848"/>
+            <a:srgbClr val="F5F6F8"/>
           </a:solidFill>
           <a:ln>
             <a:noFill/>
@@ -4609,152 +5626,14 @@
       </p:sp>
       <p:sp>
         <p:nvSpPr>
-          <p:cNvPr id="8" name="TextBox 7"/>
-          <p:cNvSpPr txBox="1"/>
-          <p:nvPr/>
-        </p:nvSpPr>
-        <p:spPr>
-          <a:xfrm>
-            <a:off x="566928" y="2651760"/>
-            <a:ext cx="457200" cy="457200"/>
-          </a:xfrm>
-          <a:prstGeom prst="rect">
-            <a:avLst/>
-          </a:prstGeom>
-          <a:noFill/>
-        </p:spPr>
-        <p:txBody>
-          <a:bodyPr wrap="square" anchor="ctr" lIns="0" rIns="0" tIns="0" bIns="0">
-            <a:spAutoFit/>
-          </a:bodyPr>
-          <a:lstStyle/>
-          <a:p>
-            <a:pPr algn="ctr">
-              <a:lnSpc>
-                <a:spcPct val="115000"/>
-              </a:lnSpc>
-              <a:spcBef>
-                <a:spcPts val="0"/>
-              </a:spcBef>
-              <a:spcAft>
-                <a:spcPts val="0"/>
-              </a:spcAft>
-            </a:pPr>
-            <a:r>
-              <a:rPr sz="1500" b="1">
-                <a:solidFill>
-                  <a:srgbClr val="FFFFFF"/>
-                </a:solidFill>
-                <a:latin typeface="Pretendard"/>
-                <a:ea typeface="Pretendard"/>
-              </a:rPr>
-              <a:t>1</a:t>
-            </a:r>
-          </a:p>
-        </p:txBody>
-      </p:sp>
-      <p:sp>
-        <p:nvSpPr>
-          <p:cNvPr id="9" name="TextBox 8"/>
-          <p:cNvSpPr txBox="1"/>
-          <p:nvPr/>
-        </p:nvSpPr>
-        <p:spPr>
-          <a:xfrm>
-            <a:off x="1188720" y="2633472"/>
-            <a:ext cx="4617720" cy="502920"/>
-          </a:xfrm>
-          <a:prstGeom prst="rect">
-            <a:avLst/>
-          </a:prstGeom>
-          <a:noFill/>
-        </p:spPr>
-        <p:txBody>
-          <a:bodyPr wrap="square" anchor="t" lIns="0" rIns="0" tIns="0" bIns="0">
-            <a:spAutoFit/>
-          </a:bodyPr>
-          <a:lstStyle/>
-          <a:p>
-            <a:pPr algn="l">
-              <a:lnSpc>
-                <a:spcPct val="115000"/>
-              </a:lnSpc>
-              <a:spcBef>
-                <a:spcPts val="0"/>
-              </a:spcBef>
-              <a:spcAft>
-                <a:spcPts val="0"/>
-              </a:spcAft>
-            </a:pPr>
-            <a:r>
-              <a:rPr sz="1500" b="1">
-                <a:solidFill>
-                  <a:srgbClr val="1A1A1A"/>
-                </a:solidFill>
-                <a:latin typeface="Pretendard"/>
-                <a:ea typeface="Pretendard"/>
-              </a:rPr>
-              <a:t>바이오시밀러</a:t>
-            </a:r>
-          </a:p>
-        </p:txBody>
-      </p:sp>
-      <p:sp>
-        <p:nvSpPr>
-          <p:cNvPr id="10" name="TextBox 9"/>
-          <p:cNvSpPr txBox="1"/>
-          <p:nvPr/>
-        </p:nvSpPr>
-        <p:spPr>
-          <a:xfrm>
-            <a:off x="566928" y="3255264"/>
-            <a:ext cx="5257800" cy="960120"/>
-          </a:xfrm>
-          <a:prstGeom prst="rect">
-            <a:avLst/>
-          </a:prstGeom>
-          <a:noFill/>
-        </p:spPr>
-        <p:txBody>
-          <a:bodyPr wrap="square" anchor="t" lIns="0" rIns="0" tIns="0" bIns="0">
-            <a:spAutoFit/>
-          </a:bodyPr>
-          <a:lstStyle/>
-          <a:p>
-            <a:pPr algn="l">
-              <a:lnSpc>
-                <a:spcPct val="135000"/>
-              </a:lnSpc>
-              <a:spcBef>
-                <a:spcPts val="0"/>
-              </a:spcBef>
-              <a:spcAft>
-                <a:spcPts val="0"/>
-              </a:spcAft>
-            </a:pPr>
-            <a:r>
-              <a:rPr sz="1150" b="0">
-                <a:solidFill>
-                  <a:srgbClr val="4A4A4A"/>
-                </a:solidFill>
-                <a:latin typeface="Pretendard"/>
-                <a:ea typeface="Pretendard"/>
-              </a:rPr>
-              <a:t>항체 바이오시밀러로 글로벌 시장 접근성을 넓힙니다.</a:t>
-            </a:r>
-          </a:p>
-        </p:txBody>
-      </p:sp>
-      <p:sp>
-        <p:nvSpPr>
-          <p:cNvPr id="11" name="Rectangle 10"/>
+          <p:cNvPr id="14" name="Rectangle 13"/>
           <p:cNvSpPr/>
           <p:nvPr/>
         </p:nvSpPr>
         <p:spPr>
           <a:xfrm>
-            <a:off x="6373368" y="2651760"/>
-            <a:ext cx="457200" cy="457200"/>
+            <a:off x="6355080" y="2724912"/>
+            <a:ext cx="82296" cy="3383280"/>
           </a:xfrm>
           <a:prstGeom prst="rect">
             <a:avLst/>
@@ -4791,60 +5670,14 @@
       </p:sp>
       <p:sp>
         <p:nvSpPr>
-          <p:cNvPr id="12" name="TextBox 11"/>
+          <p:cNvPr id="15" name="TextBox 14"/>
           <p:cNvSpPr txBox="1"/>
           <p:nvPr/>
         </p:nvSpPr>
         <p:spPr>
           <a:xfrm>
-            <a:off x="6373368" y="2651760"/>
-            <a:ext cx="457200" cy="457200"/>
-          </a:xfrm>
-          <a:prstGeom prst="rect">
-            <a:avLst/>
-          </a:prstGeom>
-          <a:noFill/>
-        </p:spPr>
-        <p:txBody>
-          <a:bodyPr wrap="square" anchor="ctr" lIns="0" rIns="0" tIns="0" bIns="0">
-            <a:spAutoFit/>
-          </a:bodyPr>
-          <a:lstStyle/>
-          <a:p>
-            <a:pPr algn="ctr">
-              <a:lnSpc>
-                <a:spcPct val="115000"/>
-              </a:lnSpc>
-              <a:spcBef>
-                <a:spcPts val="0"/>
-              </a:spcBef>
-              <a:spcAft>
-                <a:spcPts val="0"/>
-              </a:spcAft>
-            </a:pPr>
-            <a:r>
-              <a:rPr sz="1500" b="1">
-                <a:solidFill>
-                  <a:srgbClr val="FFFFFF"/>
-                </a:solidFill>
-                <a:latin typeface="Pretendard"/>
-                <a:ea typeface="Pretendard"/>
-              </a:rPr>
-              <a:t>2</a:t>
-            </a:r>
-          </a:p>
-        </p:txBody>
-      </p:sp>
-      <p:sp>
-        <p:nvSpPr>
-          <p:cNvPr id="13" name="TextBox 12"/>
-          <p:cNvSpPr txBox="1"/>
-          <p:nvPr/>
-        </p:nvSpPr>
-        <p:spPr>
-          <a:xfrm>
-            <a:off x="6995159" y="2633472"/>
-            <a:ext cx="4617720" cy="502920"/>
+            <a:off x="6739128" y="3054096"/>
+            <a:ext cx="4526280" cy="365760"/>
           </a:xfrm>
           <a:prstGeom prst="rect">
             <a:avLst/>
@@ -4869,28 +5702,28 @@
               </a:spcAft>
             </a:pPr>
             <a:r>
-              <a:rPr sz="1500" b="1">
-                <a:solidFill>
-                  <a:srgbClr val="1A1A1A"/>
+              <a:rPr sz="1200" b="1" spc="60">
+                <a:solidFill>
+                  <a:srgbClr val="2E7D32"/>
                 </a:solidFill>
                 <a:latin typeface="Pretendard"/>
                 <a:ea typeface="Pretendard"/>
               </a:rPr>
-              <a:t>신약 개발</a:t>
-            </a:r>
-          </a:p>
-        </p:txBody>
-      </p:sp>
-      <p:sp>
-        <p:nvSpPr>
-          <p:cNvPr id="14" name="TextBox 13"/>
+              <a:t>핵심 지향</a:t>
+            </a:r>
+          </a:p>
+        </p:txBody>
+      </p:sp>
+      <p:sp>
+        <p:nvSpPr>
+          <p:cNvPr id="16" name="TextBox 15"/>
           <p:cNvSpPr txBox="1"/>
           <p:nvPr/>
         </p:nvSpPr>
         <p:spPr>
           <a:xfrm>
-            <a:off x="6373368" y="3255264"/>
-            <a:ext cx="5257800" cy="960120"/>
+            <a:off x="6739128" y="3511296"/>
+            <a:ext cx="4526280" cy="1280160"/>
           </a:xfrm>
           <a:prstGeom prst="rect">
             <a:avLst/>
@@ -4905,7 +5738,7 @@
           <a:p>
             <a:pPr algn="l">
               <a:lnSpc>
-                <a:spcPct val="135000"/>
+                <a:spcPct val="130000"/>
               </a:lnSpc>
               <a:spcBef>
                 <a:spcPts val="0"/>
@@ -4915,28 +5748,238 @@
               </a:spcAft>
             </a:pPr>
             <a:r>
-              <a:rPr sz="1150" b="0">
-                <a:solidFill>
-                  <a:srgbClr val="4A4A4A"/>
+              <a:rPr sz="1500" b="1">
+                <a:solidFill>
+                  <a:srgbClr val="1A1A1A"/>
                 </a:solidFill>
                 <a:latin typeface="Pretendard"/>
                 <a:ea typeface="Pretendard"/>
               </a:rPr>
-              <a:t>신규 파이프라인으로 미래 성장 동력을 확보합니다.</a:t>
-            </a:r>
-          </a:p>
-        </p:txBody>
-      </p:sp>
-      <p:sp>
-        <p:nvSpPr>
-          <p:cNvPr id="15" name="Rectangle 14"/>
+              <a:t>바이오시밀러와 신약으로 여는 글로벌 헬스케어</a:t>
+            </a:r>
+          </a:p>
+        </p:txBody>
+      </p:sp>
+      <p:sp>
+        <p:nvSpPr>
+          <p:cNvPr id="17" name="TextBox 16"/>
+          <p:cNvSpPr txBox="1"/>
+          <p:nvPr/>
+        </p:nvSpPr>
+        <p:spPr>
+          <a:xfrm>
+            <a:off x="6739128" y="4315968"/>
+            <a:ext cx="4526280" cy="365760"/>
+          </a:xfrm>
+          <a:prstGeom prst="rect">
+            <a:avLst/>
+          </a:prstGeom>
+          <a:noFill/>
+        </p:spPr>
+        <p:txBody>
+          <a:bodyPr wrap="square" anchor="t" lIns="0" rIns="0" tIns="0" bIns="0">
+            <a:spAutoFit/>
+          </a:bodyPr>
+          <a:lstStyle/>
+          <a:p>
+            <a:pPr algn="l">
+              <a:lnSpc>
+                <a:spcPct val="115000"/>
+              </a:lnSpc>
+              <a:spcBef>
+                <a:spcPts val="0"/>
+              </a:spcBef>
+              <a:spcAft>
+                <a:spcPts val="0"/>
+              </a:spcAft>
+            </a:pPr>
+            <a:r>
+              <a:rPr sz="1200" b="0">
+                <a:solidFill>
+                  <a:srgbClr val="4A4A4A"/>
+                </a:solidFill>
+                <a:latin typeface="Pretendard"/>
+                <a:ea typeface="Pretendard"/>
+              </a:rPr>
+              <a:t>· Biosimilar</a:t>
+            </a:r>
+          </a:p>
+        </p:txBody>
+      </p:sp>
+      <p:sp>
+        <p:nvSpPr>
+          <p:cNvPr id="18" name="TextBox 17"/>
+          <p:cNvSpPr txBox="1"/>
+          <p:nvPr/>
+        </p:nvSpPr>
+        <p:spPr>
+          <a:xfrm>
+            <a:off x="6739128" y="4700016"/>
+            <a:ext cx="4526280" cy="365760"/>
+          </a:xfrm>
+          <a:prstGeom prst="rect">
+            <a:avLst/>
+          </a:prstGeom>
+          <a:noFill/>
+        </p:spPr>
+        <p:txBody>
+          <a:bodyPr wrap="square" anchor="t" lIns="0" rIns="0" tIns="0" bIns="0">
+            <a:spAutoFit/>
+          </a:bodyPr>
+          <a:lstStyle/>
+          <a:p>
+            <a:pPr algn="l">
+              <a:lnSpc>
+                <a:spcPct val="115000"/>
+              </a:lnSpc>
+              <a:spcBef>
+                <a:spcPts val="0"/>
+              </a:spcBef>
+              <a:spcAft>
+                <a:spcPts val="0"/>
+              </a:spcAft>
+            </a:pPr>
+            <a:r>
+              <a:rPr sz="1200" b="0">
+                <a:solidFill>
+                  <a:srgbClr val="4A4A4A"/>
+                </a:solidFill>
+                <a:latin typeface="Pretendard"/>
+                <a:ea typeface="Pretendard"/>
+              </a:rPr>
+              <a:t>· Novel Drug</a:t>
+            </a:r>
+          </a:p>
+        </p:txBody>
+      </p:sp>
+      <p:sp>
+        <p:nvSpPr>
+          <p:cNvPr id="19" name="TextBox 18"/>
+          <p:cNvSpPr txBox="1"/>
+          <p:nvPr/>
+        </p:nvSpPr>
+        <p:spPr>
+          <a:xfrm>
+            <a:off x="6739128" y="5084064"/>
+            <a:ext cx="4526280" cy="365760"/>
+          </a:xfrm>
+          <a:prstGeom prst="rect">
+            <a:avLst/>
+          </a:prstGeom>
+          <a:noFill/>
+        </p:spPr>
+        <p:txBody>
+          <a:bodyPr wrap="square" anchor="t" lIns="0" rIns="0" tIns="0" bIns="0">
+            <a:spAutoFit/>
+          </a:bodyPr>
+          <a:lstStyle/>
+          <a:p>
+            <a:pPr algn="l">
+              <a:lnSpc>
+                <a:spcPct val="115000"/>
+              </a:lnSpc>
+              <a:spcBef>
+                <a:spcPts val="0"/>
+              </a:spcBef>
+              <a:spcAft>
+                <a:spcPts val="0"/>
+              </a:spcAft>
+            </a:pPr>
+            <a:r>
+              <a:rPr sz="1200" b="0">
+                <a:solidFill>
+                  <a:srgbClr val="4A4A4A"/>
+                </a:solidFill>
+                <a:latin typeface="Pretendard"/>
+                <a:ea typeface="Pretendard"/>
+              </a:rPr>
+              <a:t>· Chemical</a:t>
+            </a:r>
+          </a:p>
+        </p:txBody>
+      </p:sp>
+      <p:sp>
+        <p:nvSpPr>
+          <p:cNvPr id="20" name="TextBox 19"/>
+          <p:cNvSpPr txBox="1"/>
+          <p:nvPr/>
+        </p:nvSpPr>
+        <p:spPr>
+          <a:xfrm>
+            <a:off x="6739128" y="5468112"/>
+            <a:ext cx="4526280" cy="365760"/>
+          </a:xfrm>
+          <a:prstGeom prst="rect">
+            <a:avLst/>
+          </a:prstGeom>
+          <a:noFill/>
+        </p:spPr>
+        <p:txBody>
+          <a:bodyPr wrap="square" anchor="t" lIns="0" rIns="0" tIns="0" bIns="0">
+            <a:spAutoFit/>
+          </a:bodyPr>
+          <a:lstStyle/>
+          <a:p>
+            <a:pPr algn="l">
+              <a:lnSpc>
+                <a:spcPct val="115000"/>
+              </a:lnSpc>
+              <a:spcBef>
+                <a:spcPts val="0"/>
+              </a:spcBef>
+              <a:spcAft>
+                <a:spcPts val="0"/>
+              </a:spcAft>
+            </a:pPr>
+            <a:r>
+              <a:rPr sz="1200" b="0">
+                <a:solidFill>
+                  <a:srgbClr val="4A4A4A"/>
+                </a:solidFill>
+                <a:latin typeface="Pretendard"/>
+                <a:ea typeface="Pretendard"/>
+              </a:rPr>
+              <a:t>· Global</a:t>
+            </a:r>
+          </a:p>
+        </p:txBody>
+      </p:sp>
+    </p:spTree>
+  </p:cSld>
+  <p:clrMapOvr>
+    <a:masterClrMapping/>
+  </p:clrMapOvr>
+</p:sld>
+</file>
+
+<file path=ppt/slides/slide5.xml><?xml version="1.0" encoding="utf-8"?>
+<p:sld xmlns:a="http://schemas.openxmlformats.org/drawingml/2006/main" xmlns:p="http://schemas.openxmlformats.org/presentationml/2006/main" xmlns:r="http://schemas.openxmlformats.org/officeDocument/2006/relationships">
+  <p:cSld>
+    <p:bg>
+      <p:bgPr>
+        <a:solidFill>
+          <a:srgbClr val="00552D"/>
+        </a:solidFill>
+        <a:effectLst/>
+      </p:bgPr>
+    </p:bg>
+    <p:spTree>
+      <p:nvGrpSpPr>
+        <p:cNvPr id="1" name=""/>
+        <p:cNvGrpSpPr/>
+        <p:nvPr/>
+      </p:nvGrpSpPr>
+      <p:grpSpPr/>
+      <p:sp>
+        <p:nvSpPr>
+          <p:cNvPr id="2" name="Rectangle 1"/>
           <p:cNvSpPr/>
           <p:nvPr/>
         </p:nvSpPr>
         <p:spPr>
           <a:xfrm>
-            <a:off x="566928" y="4389120"/>
-            <a:ext cx="457200" cy="457200"/>
+            <a:off x="640080" y="2788920"/>
+            <a:ext cx="822960" cy="109728"/>
           </a:xfrm>
           <a:prstGeom prst="rect">
             <a:avLst/>
@@ -4973,60 +6016,14 @@
       </p:sp>
       <p:sp>
         <p:nvSpPr>
-          <p:cNvPr id="16" name="TextBox 15"/>
+          <p:cNvPr id="3" name="TextBox 2"/>
           <p:cNvSpPr txBox="1"/>
           <p:nvPr/>
         </p:nvSpPr>
         <p:spPr>
           <a:xfrm>
-            <a:off x="566928" y="4389120"/>
-            <a:ext cx="457200" cy="457200"/>
-          </a:xfrm>
-          <a:prstGeom prst="rect">
-            <a:avLst/>
-          </a:prstGeom>
-          <a:noFill/>
-        </p:spPr>
-        <p:txBody>
-          <a:bodyPr wrap="square" anchor="ctr" lIns="0" rIns="0" tIns="0" bIns="0">
-            <a:spAutoFit/>
-          </a:bodyPr>
-          <a:lstStyle/>
-          <a:p>
-            <a:pPr algn="ctr">
-              <a:lnSpc>
-                <a:spcPct val="115000"/>
-              </a:lnSpc>
-              <a:spcBef>
-                <a:spcPts val="0"/>
-              </a:spcBef>
-              <a:spcAft>
-                <a:spcPts val="0"/>
-              </a:spcAft>
-            </a:pPr>
-            <a:r>
-              <a:rPr sz="1500" b="1">
-                <a:solidFill>
-                  <a:srgbClr val="FFFFFF"/>
-                </a:solidFill>
-                <a:latin typeface="Pretendard"/>
-                <a:ea typeface="Pretendard"/>
-              </a:rPr>
-              <a:t>3</a:t>
-            </a:r>
-          </a:p>
-        </p:txBody>
-      </p:sp>
-      <p:sp>
-        <p:nvSpPr>
-          <p:cNvPr id="17" name="TextBox 16"/>
-          <p:cNvSpPr txBox="1"/>
-          <p:nvPr/>
-        </p:nvSpPr>
-        <p:spPr>
-          <a:xfrm>
-            <a:off x="1188720" y="4370832"/>
-            <a:ext cx="4617720" cy="502920"/>
+            <a:off x="566928" y="3017520"/>
+            <a:ext cx="10972800" cy="2926080"/>
           </a:xfrm>
           <a:prstGeom prst="rect">
             <a:avLst/>
@@ -5051,242 +6048,60 @@
               </a:spcAft>
             </a:pPr>
             <a:r>
-              <a:rPr sz="1500" b="1">
-                <a:solidFill>
-                  <a:srgbClr val="1A1A1A"/>
+              <a:rPr sz="6000" b="1">
+                <a:solidFill>
+                  <a:srgbClr val="FFFFFF"/>
                 </a:solidFill>
                 <a:latin typeface="Pretendard"/>
                 <a:ea typeface="Pretendard"/>
               </a:rPr>
-              <a:t>케미컬</a:t>
-            </a:r>
-          </a:p>
-        </p:txBody>
-      </p:sp>
-      <p:sp>
-        <p:nvSpPr>
-          <p:cNvPr id="18" name="TextBox 17"/>
-          <p:cNvSpPr txBox="1"/>
-          <p:nvPr/>
-        </p:nvSpPr>
-        <p:spPr>
-          <a:xfrm>
-            <a:off x="566928" y="4992624"/>
-            <a:ext cx="5257800" cy="960120"/>
-          </a:xfrm>
-          <a:prstGeom prst="rect">
-            <a:avLst/>
-          </a:prstGeom>
-          <a:noFill/>
-        </p:spPr>
-        <p:txBody>
-          <a:bodyPr wrap="square" anchor="t" lIns="0" rIns="0" tIns="0" bIns="0">
-            <a:spAutoFit/>
-          </a:bodyPr>
-          <a:lstStyle/>
-          <a:p>
-            <a:pPr algn="l">
-              <a:lnSpc>
-                <a:spcPct val="135000"/>
-              </a:lnSpc>
-              <a:spcBef>
-                <a:spcPts val="0"/>
-              </a:spcBef>
-              <a:spcAft>
-                <a:spcPts val="0"/>
-              </a:spcAft>
-            </a:pPr>
-            <a:r>
-              <a:rPr sz="1150" b="0">
-                <a:solidFill>
-                  <a:srgbClr val="4A4A4A"/>
-                </a:solidFill>
-                <a:latin typeface="Pretendard"/>
-                <a:ea typeface="Pretendard"/>
-              </a:rPr>
-              <a:t>제네릭·개량신약으로 사업 포트폴리오를 다각화합니다.</a:t>
-            </a:r>
-          </a:p>
-        </p:txBody>
-      </p:sp>
-      <p:sp>
-        <p:nvSpPr>
-          <p:cNvPr id="19" name="Rectangle 18"/>
-          <p:cNvSpPr/>
-          <p:nvPr/>
-        </p:nvSpPr>
-        <p:spPr>
-          <a:xfrm>
-            <a:off x="6373368" y="4389120"/>
-            <a:ext cx="457200" cy="457200"/>
-          </a:xfrm>
-          <a:prstGeom prst="rect">
-            <a:avLst/>
-          </a:prstGeom>
-          <a:solidFill>
-            <a:srgbClr val="50B848"/>
-          </a:solidFill>
-          <a:ln>
-            <a:noFill/>
-          </a:ln>
-          <a:effectLst/>
-        </p:spPr>
-        <p:style>
-          <a:lnRef idx="1">
-            <a:schemeClr val="accent1"/>
-          </a:lnRef>
-          <a:fillRef idx="3">
-            <a:schemeClr val="accent1"/>
-          </a:fillRef>
-          <a:effectRef idx="2">
-            <a:schemeClr val="accent1"/>
-          </a:effectRef>
-          <a:fontRef idx="minor">
-            <a:schemeClr val="lt1"/>
-          </a:fontRef>
-        </p:style>
-        <p:txBody>
-          <a:bodyPr rtlCol="0" anchor="ctr"/>
-          <a:lstStyle/>
-          <a:p>
-            <a:pPr algn="ctr"/>
-          </a:p>
-        </p:txBody>
-      </p:sp>
-      <p:sp>
-        <p:nvSpPr>
-          <p:cNvPr id="20" name="TextBox 19"/>
-          <p:cNvSpPr txBox="1"/>
-          <p:nvPr/>
-        </p:nvSpPr>
-        <p:spPr>
-          <a:xfrm>
-            <a:off x="6373368" y="4389120"/>
-            <a:ext cx="457200" cy="457200"/>
-          </a:xfrm>
-          <a:prstGeom prst="rect">
-            <a:avLst/>
-          </a:prstGeom>
-          <a:noFill/>
-        </p:spPr>
-        <p:txBody>
-          <a:bodyPr wrap="square" anchor="ctr" lIns="0" rIns="0" tIns="0" bIns="0">
-            <a:spAutoFit/>
-          </a:bodyPr>
-          <a:lstStyle/>
-          <a:p>
-            <a:pPr algn="ctr">
-              <a:lnSpc>
-                <a:spcPct val="115000"/>
-              </a:lnSpc>
-              <a:spcBef>
-                <a:spcPts val="0"/>
-              </a:spcBef>
-              <a:spcAft>
-                <a:spcPts val="0"/>
-              </a:spcAft>
-            </a:pPr>
-            <a:r>
-              <a:rPr sz="1500" b="1">
-                <a:solidFill>
-                  <a:srgbClr val="FFFFFF"/>
-                </a:solidFill>
-                <a:latin typeface="Pretendard"/>
-                <a:ea typeface="Pretendard"/>
-              </a:rPr>
-              <a:t>4</a:t>
-            </a:r>
-          </a:p>
-        </p:txBody>
-      </p:sp>
-      <p:sp>
-        <p:nvSpPr>
-          <p:cNvPr id="21" name="TextBox 20"/>
-          <p:cNvSpPr txBox="1"/>
-          <p:nvPr/>
-        </p:nvSpPr>
-        <p:spPr>
-          <a:xfrm>
-            <a:off x="6995159" y="4370832"/>
-            <a:ext cx="4617720" cy="502920"/>
-          </a:xfrm>
-          <a:prstGeom prst="rect">
-            <a:avLst/>
-          </a:prstGeom>
-          <a:noFill/>
-        </p:spPr>
-        <p:txBody>
-          <a:bodyPr wrap="square" anchor="t" lIns="0" rIns="0" tIns="0" bIns="0">
-            <a:spAutoFit/>
-          </a:bodyPr>
-          <a:lstStyle/>
+              <a:t>02</a:t>
+            </a:r>
+          </a:p>
           <a:p>
             <a:pPr algn="l">
               <a:lnSpc>
                 <a:spcPct val="115000"/>
               </a:lnSpc>
               <a:spcBef>
-                <a:spcPts val="0"/>
+                <a:spcPts val="200"/>
               </a:spcBef>
               <a:spcAft>
                 <a:spcPts val="0"/>
               </a:spcAft>
             </a:pPr>
             <a:r>
-              <a:rPr sz="1500" b="1">
-                <a:solidFill>
-                  <a:srgbClr val="1A1A1A"/>
+              <a:rPr sz="3800" b="1">
+                <a:solidFill>
+                  <a:srgbClr val="FFFFFF"/>
                 </a:solidFill>
                 <a:latin typeface="Pretendard"/>
                 <a:ea typeface="Pretendard"/>
               </a:rPr>
-              <a:t>글로벌 헬스케어</a:t>
-            </a:r>
-          </a:p>
-        </p:txBody>
-      </p:sp>
-      <p:sp>
-        <p:nvSpPr>
-          <p:cNvPr id="22" name="TextBox 21"/>
-          <p:cNvSpPr txBox="1"/>
-          <p:nvPr/>
-        </p:nvSpPr>
-        <p:spPr>
-          <a:xfrm>
-            <a:off x="6373368" y="4992624"/>
-            <a:ext cx="5257800" cy="960120"/>
-          </a:xfrm>
-          <a:prstGeom prst="rect">
-            <a:avLst/>
-          </a:prstGeom>
-          <a:noFill/>
-        </p:spPr>
-        <p:txBody>
-          <a:bodyPr wrap="square" anchor="t" lIns="0" rIns="0" tIns="0" bIns="0">
-            <a:spAutoFit/>
-          </a:bodyPr>
-          <a:lstStyle/>
+              <a:t>핵심 사업 영역</a:t>
+            </a:r>
+          </a:p>
           <a:p>
             <a:pPr algn="l">
               <a:lnSpc>
-                <a:spcPct val="135000"/>
+                <a:spcPct val="130000"/>
               </a:lnSpc>
               <a:spcBef>
-                <a:spcPts val="0"/>
+                <a:spcPts val="1000"/>
               </a:spcBef>
               <a:spcAft>
                 <a:spcPts val="0"/>
               </a:spcAft>
             </a:pPr>
             <a:r>
-              <a:rPr sz="1150" b="0">
-                <a:solidFill>
-                  <a:srgbClr val="4A4A4A"/>
+              <a:rPr sz="1500" b="0">
+                <a:solidFill>
+                  <a:srgbClr val="FFFFFF"/>
                 </a:solidFill>
                 <a:latin typeface="Pretendard"/>
                 <a:ea typeface="Pretendard"/>
               </a:rPr>
-              <a:t>직판 체계로 세계 환자에게 직접 다가갑니다.</a:t>
+              <a:t>바이오시밀러를 넘어 신약으로</a:t>
             </a:r>
           </a:p>
         </p:txBody>
@@ -5299,7 +6114,7 @@
 </p:sld>
 </file>
 
-<file path=ppt/slides/slide5.xml><?xml version="1.0" encoding="utf-8"?>
+<file path=ppt/slides/slide6.xml><?xml version="1.0" encoding="utf-8"?>
 <p:sld xmlns:a="http://schemas.openxmlformats.org/drawingml/2006/main" xmlns:p="http://schemas.openxmlformats.org/presentationml/2006/main" xmlns:r="http://schemas.openxmlformats.org/officeDocument/2006/relationships">
   <p:cSld>
     <p:bg>
@@ -5358,7 +6173,7 @@
                 <a:latin typeface="Pretendard"/>
                 <a:ea typeface="Pretendard"/>
               </a:rPr>
-              <a:t>GROWTH</a:t>
+              <a:t>02 · 핵심 사업 영역</a:t>
             </a:r>
           </a:p>
         </p:txBody>
@@ -5404,7 +6219,7 @@
                 <a:latin typeface="Pretendard"/>
                 <a:ea typeface="Pretendard"/>
               </a:rPr>
-              <a:t>성장 지표</a:t>
+              <a:t>핵심 사업 영역</a:t>
             </a:r>
           </a:p>
         </p:txBody>
@@ -5417,7 +6232,7 @@
         </p:nvSpPr>
         <p:spPr>
           <a:xfrm>
-            <a:off x="566928" y="1609344"/>
+            <a:off x="566928" y="1627632"/>
             <a:ext cx="11064240" cy="548640"/>
           </a:xfrm>
           <a:prstGeom prst="rect">
@@ -5443,14 +6258,14 @@
               </a:spcAft>
             </a:pPr>
             <a:r>
-              <a:rPr sz="1350" b="0">
+              <a:rPr sz="1400" b="0">
                 <a:solidFill>
                   <a:srgbClr val="4A4A4A"/>
                 </a:solidFill>
                 <a:latin typeface="Pretendard"/>
                 <a:ea typeface="Pretendard"/>
               </a:rPr>
-              <a:t>바이오시밀러와 신약으로 여는 글로벌 헬스케어</a:t>
+              <a:t>바이오시밀러를 넘어 신약으로</a:t>
             </a:r>
           </a:p>
         </p:txBody>
@@ -5545,7 +6360,7 @@
       </p:sp>
       <p:pic>
         <p:nvPicPr>
-          <p:cNvPr id="7" name="Picture 6" descr="kpi_1.png"/>
+          <p:cNvPr id="7" name="Picture 6" descr="flask-conical-dc37bbed.png"/>
           <p:cNvPicPr>
             <a:picLocks noChangeAspect="1"/>
           </p:cNvPicPr>
@@ -5559,8 +6374,8 @@
         </p:blipFill>
         <p:spPr>
           <a:xfrm>
-            <a:off x="1398696" y="2514600"/>
-            <a:ext cx="9400703" cy="3566160"/>
+            <a:off x="566928" y="2670048"/>
+            <a:ext cx="402336" cy="402336"/>
           </a:xfrm>
           <a:prstGeom prst="rect">
             <a:avLst/>
@@ -5575,8 +6390,8 @@
         </p:nvSpPr>
         <p:spPr>
           <a:xfrm>
-            <a:off x="566928" y="6172200"/>
-            <a:ext cx="11064240" cy="365760"/>
+            <a:off x="566928" y="3236976"/>
+            <a:ext cx="5257800" cy="411480"/>
           </a:xfrm>
           <a:prstGeom prst="rect">
             <a:avLst/>
@@ -5601,14 +6416,408 @@
               </a:spcAft>
             </a:pPr>
             <a:r>
-              <a:rPr sz="1050" b="0">
-                <a:solidFill>
-                  <a:srgbClr val="8A8A8A"/>
+              <a:rPr sz="1450" b="1">
+                <a:solidFill>
+                  <a:srgbClr val="1A1A1A"/>
                 </a:solidFill>
                 <a:latin typeface="Pretendard"/>
                 <a:ea typeface="Pretendard"/>
               </a:rPr>
-              <a:t>※ 수치는 브랜드 테마 디자인 예시입니다 (illustrative placeholder values)</a:t>
+              <a:t>바이오시밀러</a:t>
+            </a:r>
+          </a:p>
+        </p:txBody>
+      </p:sp>
+      <p:sp>
+        <p:nvSpPr>
+          <p:cNvPr id="9" name="TextBox 8"/>
+          <p:cNvSpPr txBox="1"/>
+          <p:nvPr/>
+        </p:nvSpPr>
+        <p:spPr>
+          <a:xfrm>
+            <a:off x="566928" y="3657600"/>
+            <a:ext cx="5257800" cy="608076"/>
+          </a:xfrm>
+          <a:prstGeom prst="rect">
+            <a:avLst/>
+          </a:prstGeom>
+          <a:noFill/>
+        </p:spPr>
+        <p:txBody>
+          <a:bodyPr wrap="square" anchor="t" lIns="0" rIns="0" tIns="0" bIns="0">
+            <a:spAutoFit/>
+          </a:bodyPr>
+          <a:lstStyle/>
+          <a:p>
+            <a:pPr algn="l">
+              <a:lnSpc>
+                <a:spcPct val="140000"/>
+              </a:lnSpc>
+              <a:spcBef>
+                <a:spcPts val="0"/>
+              </a:spcBef>
+              <a:spcAft>
+                <a:spcPts val="0"/>
+              </a:spcAft>
+            </a:pPr>
+            <a:r>
+              <a:rPr sz="1200" b="0">
+                <a:solidFill>
+                  <a:srgbClr val="4A4A4A"/>
+                </a:solidFill>
+                <a:latin typeface="Pretendard"/>
+                <a:ea typeface="Pretendard"/>
+              </a:rPr>
+              <a:t>항체 바이오시밀러로 글로벌 시장 접근성을 넓힙니다.</a:t>
+            </a:r>
+          </a:p>
+        </p:txBody>
+      </p:sp>
+      <p:pic>
+        <p:nvPicPr>
+          <p:cNvPr id="10" name="Picture 9" descr="pill-1b3926a6.png"/>
+          <p:cNvPicPr>
+            <a:picLocks noChangeAspect="1"/>
+          </p:cNvPicPr>
+          <p:nvPr/>
+        </p:nvPicPr>
+        <p:blipFill>
+          <a:blip r:embed="rId3"/>
+          <a:stretch>
+            <a:fillRect/>
+          </a:stretch>
+        </p:blipFill>
+        <p:spPr>
+          <a:xfrm>
+            <a:off x="6373368" y="2670048"/>
+            <a:ext cx="402336" cy="402336"/>
+          </a:xfrm>
+          <a:prstGeom prst="rect">
+            <a:avLst/>
+          </a:prstGeom>
+        </p:spPr>
+      </p:pic>
+      <p:sp>
+        <p:nvSpPr>
+          <p:cNvPr id="11" name="TextBox 10"/>
+          <p:cNvSpPr txBox="1"/>
+          <p:nvPr/>
+        </p:nvSpPr>
+        <p:spPr>
+          <a:xfrm>
+            <a:off x="6373368" y="3236976"/>
+            <a:ext cx="5257800" cy="411480"/>
+          </a:xfrm>
+          <a:prstGeom prst="rect">
+            <a:avLst/>
+          </a:prstGeom>
+          <a:noFill/>
+        </p:spPr>
+        <p:txBody>
+          <a:bodyPr wrap="square" anchor="t" lIns="0" rIns="0" tIns="0" bIns="0">
+            <a:spAutoFit/>
+          </a:bodyPr>
+          <a:lstStyle/>
+          <a:p>
+            <a:pPr algn="l">
+              <a:lnSpc>
+                <a:spcPct val="115000"/>
+              </a:lnSpc>
+              <a:spcBef>
+                <a:spcPts val="0"/>
+              </a:spcBef>
+              <a:spcAft>
+                <a:spcPts val="0"/>
+              </a:spcAft>
+            </a:pPr>
+            <a:r>
+              <a:rPr sz="1450" b="1">
+                <a:solidFill>
+                  <a:srgbClr val="1A1A1A"/>
+                </a:solidFill>
+                <a:latin typeface="Pretendard"/>
+                <a:ea typeface="Pretendard"/>
+              </a:rPr>
+              <a:t>신약 개발</a:t>
+            </a:r>
+          </a:p>
+        </p:txBody>
+      </p:sp>
+      <p:sp>
+        <p:nvSpPr>
+          <p:cNvPr id="12" name="TextBox 11"/>
+          <p:cNvSpPr txBox="1"/>
+          <p:nvPr/>
+        </p:nvSpPr>
+        <p:spPr>
+          <a:xfrm>
+            <a:off x="6373368" y="3657600"/>
+            <a:ext cx="5257800" cy="608076"/>
+          </a:xfrm>
+          <a:prstGeom prst="rect">
+            <a:avLst/>
+          </a:prstGeom>
+          <a:noFill/>
+        </p:spPr>
+        <p:txBody>
+          <a:bodyPr wrap="square" anchor="t" lIns="0" rIns="0" tIns="0" bIns="0">
+            <a:spAutoFit/>
+          </a:bodyPr>
+          <a:lstStyle/>
+          <a:p>
+            <a:pPr algn="l">
+              <a:lnSpc>
+                <a:spcPct val="140000"/>
+              </a:lnSpc>
+              <a:spcBef>
+                <a:spcPts val="0"/>
+              </a:spcBef>
+              <a:spcAft>
+                <a:spcPts val="0"/>
+              </a:spcAft>
+            </a:pPr>
+            <a:r>
+              <a:rPr sz="1200" b="0">
+                <a:solidFill>
+                  <a:srgbClr val="4A4A4A"/>
+                </a:solidFill>
+                <a:latin typeface="Pretendard"/>
+                <a:ea typeface="Pretendard"/>
+              </a:rPr>
+              <a:t>신규 파이프라인으로 미래 성장 동력을 확보합니다.</a:t>
+            </a:r>
+          </a:p>
+        </p:txBody>
+      </p:sp>
+      <p:pic>
+        <p:nvPicPr>
+          <p:cNvPr id="13" name="Picture 12" descr="atom-d9211441.png"/>
+          <p:cNvPicPr>
+            <a:picLocks noChangeAspect="1"/>
+          </p:cNvPicPr>
+          <p:nvPr/>
+        </p:nvPicPr>
+        <p:blipFill>
+          <a:blip r:embed="rId4"/>
+          <a:stretch>
+            <a:fillRect/>
+          </a:stretch>
+        </p:blipFill>
+        <p:spPr>
+          <a:xfrm>
+            <a:off x="566928" y="4421124"/>
+            <a:ext cx="402336" cy="402336"/>
+          </a:xfrm>
+          <a:prstGeom prst="rect">
+            <a:avLst/>
+          </a:prstGeom>
+        </p:spPr>
+      </p:pic>
+      <p:sp>
+        <p:nvSpPr>
+          <p:cNvPr id="14" name="TextBox 13"/>
+          <p:cNvSpPr txBox="1"/>
+          <p:nvPr/>
+        </p:nvSpPr>
+        <p:spPr>
+          <a:xfrm>
+            <a:off x="566928" y="4988052"/>
+            <a:ext cx="5257800" cy="411480"/>
+          </a:xfrm>
+          <a:prstGeom prst="rect">
+            <a:avLst/>
+          </a:prstGeom>
+          <a:noFill/>
+        </p:spPr>
+        <p:txBody>
+          <a:bodyPr wrap="square" anchor="t" lIns="0" rIns="0" tIns="0" bIns="0">
+            <a:spAutoFit/>
+          </a:bodyPr>
+          <a:lstStyle/>
+          <a:p>
+            <a:pPr algn="l">
+              <a:lnSpc>
+                <a:spcPct val="115000"/>
+              </a:lnSpc>
+              <a:spcBef>
+                <a:spcPts val="0"/>
+              </a:spcBef>
+              <a:spcAft>
+                <a:spcPts val="0"/>
+              </a:spcAft>
+            </a:pPr>
+            <a:r>
+              <a:rPr sz="1450" b="1">
+                <a:solidFill>
+                  <a:srgbClr val="1A1A1A"/>
+                </a:solidFill>
+                <a:latin typeface="Pretendard"/>
+                <a:ea typeface="Pretendard"/>
+              </a:rPr>
+              <a:t>케미컬</a:t>
+            </a:r>
+          </a:p>
+        </p:txBody>
+      </p:sp>
+      <p:sp>
+        <p:nvSpPr>
+          <p:cNvPr id="15" name="TextBox 14"/>
+          <p:cNvSpPr txBox="1"/>
+          <p:nvPr/>
+        </p:nvSpPr>
+        <p:spPr>
+          <a:xfrm>
+            <a:off x="566928" y="5408676"/>
+            <a:ext cx="5257800" cy="608076"/>
+          </a:xfrm>
+          <a:prstGeom prst="rect">
+            <a:avLst/>
+          </a:prstGeom>
+          <a:noFill/>
+        </p:spPr>
+        <p:txBody>
+          <a:bodyPr wrap="square" anchor="t" lIns="0" rIns="0" tIns="0" bIns="0">
+            <a:spAutoFit/>
+          </a:bodyPr>
+          <a:lstStyle/>
+          <a:p>
+            <a:pPr algn="l">
+              <a:lnSpc>
+                <a:spcPct val="140000"/>
+              </a:lnSpc>
+              <a:spcBef>
+                <a:spcPts val="0"/>
+              </a:spcBef>
+              <a:spcAft>
+                <a:spcPts val="0"/>
+              </a:spcAft>
+            </a:pPr>
+            <a:r>
+              <a:rPr sz="1200" b="0">
+                <a:solidFill>
+                  <a:srgbClr val="4A4A4A"/>
+                </a:solidFill>
+                <a:latin typeface="Pretendard"/>
+                <a:ea typeface="Pretendard"/>
+              </a:rPr>
+              <a:t>제네릭·개량신약으로 사업 포트폴리오를 다각화합니다.</a:t>
+            </a:r>
+          </a:p>
+        </p:txBody>
+      </p:sp>
+      <p:pic>
+        <p:nvPicPr>
+          <p:cNvPr id="16" name="Picture 15" descr="globe-2e6d8916.png"/>
+          <p:cNvPicPr>
+            <a:picLocks noChangeAspect="1"/>
+          </p:cNvPicPr>
+          <p:nvPr/>
+        </p:nvPicPr>
+        <p:blipFill>
+          <a:blip r:embed="rId5"/>
+          <a:stretch>
+            <a:fillRect/>
+          </a:stretch>
+        </p:blipFill>
+        <p:spPr>
+          <a:xfrm>
+            <a:off x="6373368" y="4421124"/>
+            <a:ext cx="402336" cy="402336"/>
+          </a:xfrm>
+          <a:prstGeom prst="rect">
+            <a:avLst/>
+          </a:prstGeom>
+        </p:spPr>
+      </p:pic>
+      <p:sp>
+        <p:nvSpPr>
+          <p:cNvPr id="17" name="TextBox 16"/>
+          <p:cNvSpPr txBox="1"/>
+          <p:nvPr/>
+        </p:nvSpPr>
+        <p:spPr>
+          <a:xfrm>
+            <a:off x="6373368" y="4988052"/>
+            <a:ext cx="5257800" cy="411480"/>
+          </a:xfrm>
+          <a:prstGeom prst="rect">
+            <a:avLst/>
+          </a:prstGeom>
+          <a:noFill/>
+        </p:spPr>
+        <p:txBody>
+          <a:bodyPr wrap="square" anchor="t" lIns="0" rIns="0" tIns="0" bIns="0">
+            <a:spAutoFit/>
+          </a:bodyPr>
+          <a:lstStyle/>
+          <a:p>
+            <a:pPr algn="l">
+              <a:lnSpc>
+                <a:spcPct val="115000"/>
+              </a:lnSpc>
+              <a:spcBef>
+                <a:spcPts val="0"/>
+              </a:spcBef>
+              <a:spcAft>
+                <a:spcPts val="0"/>
+              </a:spcAft>
+            </a:pPr>
+            <a:r>
+              <a:rPr sz="1450" b="1">
+                <a:solidFill>
+                  <a:srgbClr val="1A1A1A"/>
+                </a:solidFill>
+                <a:latin typeface="Pretendard"/>
+                <a:ea typeface="Pretendard"/>
+              </a:rPr>
+              <a:t>글로벌 헬스케어</a:t>
+            </a:r>
+          </a:p>
+        </p:txBody>
+      </p:sp>
+      <p:sp>
+        <p:nvSpPr>
+          <p:cNvPr id="18" name="TextBox 17"/>
+          <p:cNvSpPr txBox="1"/>
+          <p:nvPr/>
+        </p:nvSpPr>
+        <p:spPr>
+          <a:xfrm>
+            <a:off x="6373368" y="5408676"/>
+            <a:ext cx="5257800" cy="608076"/>
+          </a:xfrm>
+          <a:prstGeom prst="rect">
+            <a:avLst/>
+          </a:prstGeom>
+          <a:noFill/>
+        </p:spPr>
+        <p:txBody>
+          <a:bodyPr wrap="square" anchor="t" lIns="0" rIns="0" tIns="0" bIns="0">
+            <a:spAutoFit/>
+          </a:bodyPr>
+          <a:lstStyle/>
+          <a:p>
+            <a:pPr algn="l">
+              <a:lnSpc>
+                <a:spcPct val="140000"/>
+              </a:lnSpc>
+              <a:spcBef>
+                <a:spcPts val="0"/>
+              </a:spcBef>
+              <a:spcAft>
+                <a:spcPts val="0"/>
+              </a:spcAft>
+            </a:pPr>
+            <a:r>
+              <a:rPr sz="1200" b="0">
+                <a:solidFill>
+                  <a:srgbClr val="4A4A4A"/>
+                </a:solidFill>
+                <a:latin typeface="Pretendard"/>
+                <a:ea typeface="Pretendard"/>
+              </a:rPr>
+              <a:t>직판 체계로 세계 환자에게 직접 다가갑니다.</a:t>
             </a:r>
           </a:p>
         </p:txBody>
@@ -5621,13 +6830,13 @@
 </p:sld>
 </file>
 
-<file path=ppt/slides/slide6.xml><?xml version="1.0" encoding="utf-8"?>
+<file path=ppt/slides/slide7.xml><?xml version="1.0" encoding="utf-8"?>
 <p:sld xmlns:a="http://schemas.openxmlformats.org/drawingml/2006/main" xmlns:p="http://schemas.openxmlformats.org/presentationml/2006/main" xmlns:r="http://schemas.openxmlformats.org/officeDocument/2006/relationships">
   <p:cSld>
     <p:bg>
       <p:bgPr>
         <a:solidFill>
-          <a:srgbClr val="00552D"/>
+          <a:srgbClr val="FFFFFF"/>
         </a:solidFill>
         <a:effectLst/>
       </p:bgPr>
@@ -5641,14 +6850,152 @@
       <p:grpSpPr/>
       <p:sp>
         <p:nvSpPr>
-          <p:cNvPr id="2" name="Rectangle 1"/>
+          <p:cNvPr id="2" name="TextBox 1"/>
+          <p:cNvSpPr txBox="1"/>
+          <p:nvPr/>
+        </p:nvSpPr>
+        <p:spPr>
+          <a:xfrm>
+            <a:off x="566928" y="402336"/>
+            <a:ext cx="8686800" cy="292608"/>
+          </a:xfrm>
+          <a:prstGeom prst="rect">
+            <a:avLst/>
+          </a:prstGeom>
+          <a:noFill/>
+        </p:spPr>
+        <p:txBody>
+          <a:bodyPr wrap="square" anchor="t" lIns="0" rIns="0" tIns="0" bIns="0">
+            <a:spAutoFit/>
+          </a:bodyPr>
+          <a:lstStyle/>
+          <a:p>
+            <a:pPr algn="l">
+              <a:lnSpc>
+                <a:spcPct val="115000"/>
+              </a:lnSpc>
+              <a:spcBef>
+                <a:spcPts val="0"/>
+              </a:spcBef>
+              <a:spcAft>
+                <a:spcPts val="0"/>
+              </a:spcAft>
+            </a:pPr>
+            <a:r>
+              <a:rPr sz="1100" b="1" spc="120">
+                <a:solidFill>
+                  <a:srgbClr val="2E7D32"/>
+                </a:solidFill>
+                <a:latin typeface="Pretendard"/>
+                <a:ea typeface="Pretendard"/>
+              </a:rPr>
+              <a:t>03 · 성장 전략</a:t>
+            </a:r>
+          </a:p>
+        </p:txBody>
+      </p:sp>
+      <p:sp>
+        <p:nvSpPr>
+          <p:cNvPr id="3" name="TextBox 2"/>
+          <p:cNvSpPr txBox="1"/>
+          <p:nvPr/>
+        </p:nvSpPr>
+        <p:spPr>
+          <a:xfrm>
+            <a:off x="566928" y="841248"/>
+            <a:ext cx="11064240" cy="914400"/>
+          </a:xfrm>
+          <a:prstGeom prst="rect">
+            <a:avLst/>
+          </a:prstGeom>
+          <a:noFill/>
+        </p:spPr>
+        <p:txBody>
+          <a:bodyPr wrap="square" anchor="t" lIns="0" rIns="0" tIns="0" bIns="0">
+            <a:spAutoFit/>
+          </a:bodyPr>
+          <a:lstStyle/>
+          <a:p>
+            <a:pPr algn="l">
+              <a:lnSpc>
+                <a:spcPct val="115000"/>
+              </a:lnSpc>
+              <a:spcBef>
+                <a:spcPts val="0"/>
+              </a:spcBef>
+              <a:spcAft>
+                <a:spcPts val="0"/>
+              </a:spcAft>
+            </a:pPr>
+            <a:r>
+              <a:rPr sz="2500" b="1">
+                <a:solidFill>
+                  <a:srgbClr val="1A1A1A"/>
+                </a:solidFill>
+                <a:latin typeface="Pretendard"/>
+                <a:ea typeface="Pretendard"/>
+              </a:rPr>
+              <a:t>현재에서 확대 방향으로</a:t>
+            </a:r>
+          </a:p>
+        </p:txBody>
+      </p:sp>
+      <p:sp>
+        <p:nvSpPr>
+          <p:cNvPr id="4" name="TextBox 3"/>
+          <p:cNvSpPr txBox="1"/>
+          <p:nvPr/>
+        </p:nvSpPr>
+        <p:spPr>
+          <a:xfrm>
+            <a:off x="566928" y="1627632"/>
+            <a:ext cx="11064240" cy="548640"/>
+          </a:xfrm>
+          <a:prstGeom prst="rect">
+            <a:avLst/>
+          </a:prstGeom>
+          <a:noFill/>
+        </p:spPr>
+        <p:txBody>
+          <a:bodyPr wrap="square" anchor="t" lIns="0" rIns="0" tIns="0" bIns="0">
+            <a:spAutoFit/>
+          </a:bodyPr>
+          <a:lstStyle/>
+          <a:p>
+            <a:pPr algn="l">
+              <a:lnSpc>
+                <a:spcPct val="115000"/>
+              </a:lnSpc>
+              <a:spcBef>
+                <a:spcPts val="0"/>
+              </a:spcBef>
+              <a:spcAft>
+                <a:spcPts val="0"/>
+              </a:spcAft>
+            </a:pPr>
+            <a:r>
+              <a:rPr sz="1400" b="0">
+                <a:solidFill>
+                  <a:srgbClr val="4A4A4A"/>
+                </a:solidFill>
+                <a:latin typeface="Pretendard"/>
+                <a:ea typeface="Pretendard"/>
+              </a:rPr>
+              <a:t>각 사업 영역의 현재와 확대 방향 (표기는 예시)</a:t>
+            </a:r>
+          </a:p>
+        </p:txBody>
+      </p:sp>
+      <p:sp>
+        <p:nvSpPr>
+          <p:cNvPr id="5" name="Rectangle 4"/>
           <p:cNvSpPr/>
           <p:nvPr/>
         </p:nvSpPr>
         <p:spPr>
           <a:xfrm>
-            <a:off x="640080" y="2651760"/>
-            <a:ext cx="822960" cy="109728"/>
+            <a:off x="566928" y="2194560"/>
+            <a:ext cx="1005840" cy="41148"/>
           </a:xfrm>
           <a:prstGeom prst="rect">
             <a:avLst/>
@@ -5685,14 +7032,108 @@
       </p:sp>
       <p:sp>
         <p:nvSpPr>
-          <p:cNvPr id="3" name="TextBox 2"/>
+          <p:cNvPr id="6" name="Rectangle 5"/>
+          <p:cNvSpPr/>
+          <p:nvPr/>
+        </p:nvSpPr>
+        <p:spPr>
+          <a:xfrm>
+            <a:off x="1572768" y="2211019"/>
+            <a:ext cx="10058400" cy="10972"/>
+          </a:xfrm>
+          <a:prstGeom prst="rect">
+            <a:avLst/>
+          </a:prstGeom>
+          <a:solidFill>
+            <a:srgbClr val="E1E3E8"/>
+          </a:solidFill>
+          <a:ln>
+            <a:noFill/>
+          </a:ln>
+          <a:effectLst/>
+        </p:spPr>
+        <p:style>
+          <a:lnRef idx="1">
+            <a:schemeClr val="accent1"/>
+          </a:lnRef>
+          <a:fillRef idx="3">
+            <a:schemeClr val="accent1"/>
+          </a:fillRef>
+          <a:effectRef idx="2">
+            <a:schemeClr val="accent1"/>
+          </a:effectRef>
+          <a:fontRef idx="minor">
+            <a:schemeClr val="lt1"/>
+          </a:fontRef>
+        </p:style>
+        <p:txBody>
+          <a:bodyPr rtlCol="0" anchor="ctr"/>
+          <a:lstStyle/>
+          <a:p>
+            <a:pPr algn="ctr"/>
+          </a:p>
+        </p:txBody>
+      </p:sp>
+      <p:pic>
+        <p:nvPicPr>
+          <p:cNvPr id="7" name="Picture 6" descr="table_1.png"/>
+          <p:cNvPicPr>
+            <a:picLocks noChangeAspect="1"/>
+          </p:cNvPicPr>
+          <p:nvPr/>
+        </p:nvPicPr>
+        <p:blipFill>
+          <a:blip r:embed="rId2"/>
+          <a:stretch>
+            <a:fillRect/>
+          </a:stretch>
+        </p:blipFill>
+        <p:spPr>
+          <a:xfrm>
+            <a:off x="1949252" y="2468880"/>
+            <a:ext cx="8299591" cy="3657600"/>
+          </a:xfrm>
+          <a:prstGeom prst="rect">
+            <a:avLst/>
+          </a:prstGeom>
+        </p:spPr>
+      </p:pic>
+    </p:spTree>
+  </p:cSld>
+  <p:clrMapOvr>
+    <a:masterClrMapping/>
+  </p:clrMapOvr>
+</p:sld>
+</file>
+
+<file path=ppt/slides/slide8.xml><?xml version="1.0" encoding="utf-8"?>
+<p:sld xmlns:a="http://schemas.openxmlformats.org/drawingml/2006/main" xmlns:p="http://schemas.openxmlformats.org/presentationml/2006/main" xmlns:r="http://schemas.openxmlformats.org/officeDocument/2006/relationships">
+  <p:cSld>
+    <p:bg>
+      <p:bgPr>
+        <a:solidFill>
+          <a:srgbClr val="FFFFFF"/>
+        </a:solidFill>
+        <a:effectLst/>
+      </p:bgPr>
+    </p:bg>
+    <p:spTree>
+      <p:nvGrpSpPr>
+        <p:cNvPr id="1" name=""/>
+        <p:cNvGrpSpPr/>
+        <p:nvPr/>
+      </p:nvGrpSpPr>
+      <p:grpSpPr/>
+      <p:sp>
+        <p:nvSpPr>
+          <p:cNvPr id="2" name="TextBox 1"/>
           <p:cNvSpPr txBox="1"/>
           <p:nvPr/>
         </p:nvSpPr>
         <p:spPr>
           <a:xfrm>
-            <a:off x="566928" y="2880360"/>
-            <a:ext cx="11064240" cy="2377440"/>
+            <a:off x="566928" y="402336"/>
+            <a:ext cx="8686800" cy="292608"/>
           </a:xfrm>
           <a:prstGeom prst="rect">
             <a:avLst/>
@@ -5717,52 +7158,28 @@
               </a:spcAft>
             </a:pPr>
             <a:r>
-              <a:rPr sz="4000" b="1">
-                <a:solidFill>
-                  <a:srgbClr val="FFFFFF"/>
+              <a:rPr sz="1100" b="1" spc="120">
+                <a:solidFill>
+                  <a:srgbClr val="2E7D32"/>
                 </a:solidFill>
                 <a:latin typeface="Pretendard"/>
                 <a:ea typeface="Pretendard"/>
               </a:rPr>
-              <a:t>건강한 미래를
-함께 만듭니다</a:t>
-            </a:r>
-          </a:p>
-          <a:p>
-            <a:pPr algn="l">
-              <a:lnSpc>
-                <a:spcPct val="135000"/>
-              </a:lnSpc>
-              <a:spcBef>
-                <a:spcPts val="1200"/>
-              </a:spcBef>
-              <a:spcAft>
-                <a:spcPts val="0"/>
-              </a:spcAft>
-            </a:pPr>
-            <a:r>
-              <a:rPr sz="1500" b="0">
-                <a:solidFill>
-                  <a:srgbClr val="FFFFFF"/>
-                </a:solidFill>
-                <a:latin typeface="Pretendard"/>
-                <a:ea typeface="Pretendard"/>
-              </a:rPr>
-              <a:t>Celltrion</a:t>
-            </a:r>
-          </a:p>
-        </p:txBody>
-      </p:sp>
-      <p:sp>
-        <p:nvSpPr>
-          <p:cNvPr id="4" name="TextBox 3"/>
+              <a:t>03 · 성장 전략</a:t>
+            </a:r>
+          </a:p>
+        </p:txBody>
+      </p:sp>
+      <p:sp>
+        <p:nvSpPr>
+          <p:cNvPr id="3" name="TextBox 2"/>
           <p:cNvSpPr txBox="1"/>
           <p:nvPr/>
         </p:nvSpPr>
         <p:spPr>
           <a:xfrm>
-            <a:off x="566928" y="6035040"/>
-            <a:ext cx="11064240" cy="365760"/>
+            <a:off x="566928" y="841248"/>
+            <a:ext cx="11064240" cy="914400"/>
           </a:xfrm>
           <a:prstGeom prst="rect">
             <a:avLst/>
@@ -5787,18 +7204,1026 @@
               </a:spcAft>
             </a:pPr>
             <a:r>
-              <a:rPr sz="1100" b="0">
-                <a:solidFill>
-                  <a:srgbClr val="FFFFFF"/>
+              <a:rPr sz="2500" b="1">
+                <a:solidFill>
+                  <a:srgbClr val="1A1A1A"/>
                 </a:solidFill>
                 <a:latin typeface="Pretendard"/>
                 <a:ea typeface="Pretendard"/>
               </a:rPr>
-              <a:t>brand-inspired sample deck · 상표는 셀트리온 (Celltrion, Inc.)의 자산입니다</a:t>
-            </a:r>
-          </a:p>
-        </p:txBody>
-      </p:sp>
+              <a:t>성장 전략 4대 축</a:t>
+            </a:r>
+          </a:p>
+        </p:txBody>
+      </p:sp>
+      <p:sp>
+        <p:nvSpPr>
+          <p:cNvPr id="4" name="TextBox 3"/>
+          <p:cNvSpPr txBox="1"/>
+          <p:nvPr/>
+        </p:nvSpPr>
+        <p:spPr>
+          <a:xfrm>
+            <a:off x="566928" y="1627632"/>
+            <a:ext cx="11064240" cy="548640"/>
+          </a:xfrm>
+          <a:prstGeom prst="rect">
+            <a:avLst/>
+          </a:prstGeom>
+          <a:noFill/>
+        </p:spPr>
+        <p:txBody>
+          <a:bodyPr wrap="square" anchor="t" lIns="0" rIns="0" tIns="0" bIns="0">
+            <a:spAutoFit/>
+          </a:bodyPr>
+          <a:lstStyle/>
+          <a:p>
+            <a:pPr algn="l">
+              <a:lnSpc>
+                <a:spcPct val="115000"/>
+              </a:lnSpc>
+              <a:spcBef>
+                <a:spcPts val="0"/>
+              </a:spcBef>
+              <a:spcAft>
+                <a:spcPts val="0"/>
+              </a:spcAft>
+            </a:pPr>
+            <a:r>
+              <a:rPr sz="1400" b="0">
+                <a:solidFill>
+                  <a:srgbClr val="4A4A4A"/>
+                </a:solidFill>
+                <a:latin typeface="Pretendard"/>
+                <a:ea typeface="Pretendard"/>
+              </a:rPr>
+              <a:t>바이오시밀러와 신약으로 여는 글로벌 헬스케어</a:t>
+            </a:r>
+          </a:p>
+        </p:txBody>
+      </p:sp>
+      <p:sp>
+        <p:nvSpPr>
+          <p:cNvPr id="5" name="Rectangle 4"/>
+          <p:cNvSpPr/>
+          <p:nvPr/>
+        </p:nvSpPr>
+        <p:spPr>
+          <a:xfrm>
+            <a:off x="566928" y="2194560"/>
+            <a:ext cx="1005840" cy="41148"/>
+          </a:xfrm>
+          <a:prstGeom prst="rect">
+            <a:avLst/>
+          </a:prstGeom>
+          <a:solidFill>
+            <a:srgbClr val="50B848"/>
+          </a:solidFill>
+          <a:ln>
+            <a:noFill/>
+          </a:ln>
+          <a:effectLst/>
+        </p:spPr>
+        <p:style>
+          <a:lnRef idx="1">
+            <a:schemeClr val="accent1"/>
+          </a:lnRef>
+          <a:fillRef idx="3">
+            <a:schemeClr val="accent1"/>
+          </a:fillRef>
+          <a:effectRef idx="2">
+            <a:schemeClr val="accent1"/>
+          </a:effectRef>
+          <a:fontRef idx="minor">
+            <a:schemeClr val="lt1"/>
+          </a:fontRef>
+        </p:style>
+        <p:txBody>
+          <a:bodyPr rtlCol="0" anchor="ctr"/>
+          <a:lstStyle/>
+          <a:p>
+            <a:pPr algn="ctr"/>
+          </a:p>
+        </p:txBody>
+      </p:sp>
+      <p:sp>
+        <p:nvSpPr>
+          <p:cNvPr id="6" name="Rectangle 5"/>
+          <p:cNvSpPr/>
+          <p:nvPr/>
+        </p:nvSpPr>
+        <p:spPr>
+          <a:xfrm>
+            <a:off x="1572768" y="2211019"/>
+            <a:ext cx="10058400" cy="10972"/>
+          </a:xfrm>
+          <a:prstGeom prst="rect">
+            <a:avLst/>
+          </a:prstGeom>
+          <a:solidFill>
+            <a:srgbClr val="E1E3E8"/>
+          </a:solidFill>
+          <a:ln>
+            <a:noFill/>
+          </a:ln>
+          <a:effectLst/>
+        </p:spPr>
+        <p:style>
+          <a:lnRef idx="1">
+            <a:schemeClr val="accent1"/>
+          </a:lnRef>
+          <a:fillRef idx="3">
+            <a:schemeClr val="accent1"/>
+          </a:fillRef>
+          <a:effectRef idx="2">
+            <a:schemeClr val="accent1"/>
+          </a:effectRef>
+          <a:fontRef idx="minor">
+            <a:schemeClr val="lt1"/>
+          </a:fontRef>
+        </p:style>
+        <p:txBody>
+          <a:bodyPr rtlCol="0" anchor="ctr"/>
+          <a:lstStyle/>
+          <a:p>
+            <a:pPr algn="ctr"/>
+          </a:p>
+        </p:txBody>
+      </p:sp>
+      <p:sp>
+        <p:nvSpPr>
+          <p:cNvPr id="7" name="TextBox 6"/>
+          <p:cNvSpPr txBox="1"/>
+          <p:nvPr/>
+        </p:nvSpPr>
+        <p:spPr>
+          <a:xfrm>
+            <a:off x="566928" y="2697480"/>
+            <a:ext cx="3017520" cy="3291840"/>
+          </a:xfrm>
+          <a:prstGeom prst="rect">
+            <a:avLst/>
+          </a:prstGeom>
+          <a:noFill/>
+        </p:spPr>
+        <p:txBody>
+          <a:bodyPr wrap="square" anchor="t" lIns="0" rIns="0" tIns="0" bIns="0">
+            <a:spAutoFit/>
+          </a:bodyPr>
+          <a:lstStyle/>
+          <a:p>
+            <a:pPr algn="l">
+              <a:lnSpc>
+                <a:spcPct val="150000"/>
+              </a:lnSpc>
+              <a:spcBef>
+                <a:spcPts val="0"/>
+              </a:spcBef>
+              <a:spcAft>
+                <a:spcPts val="0"/>
+              </a:spcAft>
+            </a:pPr>
+            <a:r>
+              <a:rPr sz="1250" b="0">
+                <a:solidFill>
+                  <a:srgbClr val="4A4A4A"/>
+                </a:solidFill>
+                <a:latin typeface="Pretendard"/>
+                <a:ea typeface="Pretendard"/>
+              </a:rPr>
+              <a:t>바이오시밀러와 신약으로 여는 글로벌 헬스케어</a:t>
+            </a:r>
+          </a:p>
+        </p:txBody>
+      </p:sp>
+      <p:sp>
+        <p:nvSpPr>
+          <p:cNvPr id="8" name="TextBox 7"/>
+          <p:cNvSpPr txBox="1"/>
+          <p:nvPr/>
+        </p:nvSpPr>
+        <p:spPr>
+          <a:xfrm>
+            <a:off x="4023360" y="2651760"/>
+            <a:ext cx="868680" cy="548640"/>
+          </a:xfrm>
+          <a:prstGeom prst="rect">
+            <a:avLst/>
+          </a:prstGeom>
+          <a:noFill/>
+        </p:spPr>
+        <p:txBody>
+          <a:bodyPr wrap="square" anchor="t" lIns="0" rIns="0" tIns="0" bIns="0">
+            <a:spAutoFit/>
+          </a:bodyPr>
+          <a:lstStyle/>
+          <a:p>
+            <a:pPr algn="l">
+              <a:lnSpc>
+                <a:spcPct val="115000"/>
+              </a:lnSpc>
+              <a:spcBef>
+                <a:spcPts val="0"/>
+              </a:spcBef>
+              <a:spcAft>
+                <a:spcPts val="0"/>
+              </a:spcAft>
+            </a:pPr>
+            <a:r>
+              <a:rPr sz="2100" b="1">
+                <a:solidFill>
+                  <a:srgbClr val="2E7D32"/>
+                </a:solidFill>
+                <a:latin typeface="Pretendard"/>
+                <a:ea typeface="Pretendard"/>
+              </a:rPr>
+              <a:t>01</a:t>
+            </a:r>
+          </a:p>
+        </p:txBody>
+      </p:sp>
+      <p:sp>
+        <p:nvSpPr>
+          <p:cNvPr id="9" name="TextBox 8"/>
+          <p:cNvSpPr txBox="1"/>
+          <p:nvPr/>
+        </p:nvSpPr>
+        <p:spPr>
+          <a:xfrm>
+            <a:off x="4937760" y="2651760"/>
+            <a:ext cx="6675119" cy="384048"/>
+          </a:xfrm>
+          <a:prstGeom prst="rect">
+            <a:avLst/>
+          </a:prstGeom>
+          <a:noFill/>
+        </p:spPr>
+        <p:txBody>
+          <a:bodyPr wrap="square" anchor="t" lIns="0" rIns="0" tIns="0" bIns="0">
+            <a:spAutoFit/>
+          </a:bodyPr>
+          <a:lstStyle/>
+          <a:p>
+            <a:pPr algn="l">
+              <a:lnSpc>
+                <a:spcPct val="115000"/>
+              </a:lnSpc>
+              <a:spcBef>
+                <a:spcPts val="0"/>
+              </a:spcBef>
+              <a:spcAft>
+                <a:spcPts val="0"/>
+              </a:spcAft>
+            </a:pPr>
+            <a:r>
+              <a:rPr sz="1400" b="1">
+                <a:solidFill>
+                  <a:srgbClr val="1A1A1A"/>
+                </a:solidFill>
+                <a:latin typeface="Pretendard"/>
+                <a:ea typeface="Pretendard"/>
+              </a:rPr>
+              <a:t>파이프라인 확대</a:t>
+            </a:r>
+          </a:p>
+        </p:txBody>
+      </p:sp>
+      <p:sp>
+        <p:nvSpPr>
+          <p:cNvPr id="10" name="TextBox 9"/>
+          <p:cNvSpPr txBox="1"/>
+          <p:nvPr/>
+        </p:nvSpPr>
+        <p:spPr>
+          <a:xfrm>
+            <a:off x="4937760" y="3035808"/>
+            <a:ext cx="6675119" cy="422910"/>
+          </a:xfrm>
+          <a:prstGeom prst="rect">
+            <a:avLst/>
+          </a:prstGeom>
+          <a:noFill/>
+        </p:spPr>
+        <p:txBody>
+          <a:bodyPr wrap="square" anchor="t" lIns="0" rIns="0" tIns="0" bIns="0">
+            <a:spAutoFit/>
+          </a:bodyPr>
+          <a:lstStyle/>
+          <a:p>
+            <a:pPr algn="l">
+              <a:lnSpc>
+                <a:spcPct val="132000"/>
+              </a:lnSpc>
+              <a:spcBef>
+                <a:spcPts val="0"/>
+              </a:spcBef>
+              <a:spcAft>
+                <a:spcPts val="0"/>
+              </a:spcAft>
+            </a:pPr>
+            <a:r>
+              <a:rPr sz="1150" b="0">
+                <a:solidFill>
+                  <a:srgbClr val="4A4A4A"/>
+                </a:solidFill>
+                <a:latin typeface="Pretendard"/>
+                <a:ea typeface="Pretendard"/>
+              </a:rPr>
+              <a:t>바이오시밀러 제품군을 넓힙니다.</a:t>
+            </a:r>
+          </a:p>
+        </p:txBody>
+      </p:sp>
+      <p:sp>
+        <p:nvSpPr>
+          <p:cNvPr id="11" name="TextBox 10"/>
+          <p:cNvSpPr txBox="1"/>
+          <p:nvPr/>
+        </p:nvSpPr>
+        <p:spPr>
+          <a:xfrm>
+            <a:off x="4023360" y="3531870"/>
+            <a:ext cx="868680" cy="548640"/>
+          </a:xfrm>
+          <a:prstGeom prst="rect">
+            <a:avLst/>
+          </a:prstGeom>
+          <a:noFill/>
+        </p:spPr>
+        <p:txBody>
+          <a:bodyPr wrap="square" anchor="t" lIns="0" rIns="0" tIns="0" bIns="0">
+            <a:spAutoFit/>
+          </a:bodyPr>
+          <a:lstStyle/>
+          <a:p>
+            <a:pPr algn="l">
+              <a:lnSpc>
+                <a:spcPct val="115000"/>
+              </a:lnSpc>
+              <a:spcBef>
+                <a:spcPts val="0"/>
+              </a:spcBef>
+              <a:spcAft>
+                <a:spcPts val="0"/>
+              </a:spcAft>
+            </a:pPr>
+            <a:r>
+              <a:rPr sz="2100" b="1">
+                <a:solidFill>
+                  <a:srgbClr val="2E7D32"/>
+                </a:solidFill>
+                <a:latin typeface="Pretendard"/>
+                <a:ea typeface="Pretendard"/>
+              </a:rPr>
+              <a:t>02</a:t>
+            </a:r>
+          </a:p>
+        </p:txBody>
+      </p:sp>
+      <p:sp>
+        <p:nvSpPr>
+          <p:cNvPr id="12" name="TextBox 11"/>
+          <p:cNvSpPr txBox="1"/>
+          <p:nvPr/>
+        </p:nvSpPr>
+        <p:spPr>
+          <a:xfrm>
+            <a:off x="4937760" y="3531870"/>
+            <a:ext cx="6675119" cy="384048"/>
+          </a:xfrm>
+          <a:prstGeom prst="rect">
+            <a:avLst/>
+          </a:prstGeom>
+          <a:noFill/>
+        </p:spPr>
+        <p:txBody>
+          <a:bodyPr wrap="square" anchor="t" lIns="0" rIns="0" tIns="0" bIns="0">
+            <a:spAutoFit/>
+          </a:bodyPr>
+          <a:lstStyle/>
+          <a:p>
+            <a:pPr algn="l">
+              <a:lnSpc>
+                <a:spcPct val="115000"/>
+              </a:lnSpc>
+              <a:spcBef>
+                <a:spcPts val="0"/>
+              </a:spcBef>
+              <a:spcAft>
+                <a:spcPts val="0"/>
+              </a:spcAft>
+            </a:pPr>
+            <a:r>
+              <a:rPr sz="1400" b="1">
+                <a:solidFill>
+                  <a:srgbClr val="1A1A1A"/>
+                </a:solidFill>
+                <a:latin typeface="Pretendard"/>
+                <a:ea typeface="Pretendard"/>
+              </a:rPr>
+              <a:t>신약 개발</a:t>
+            </a:r>
+          </a:p>
+        </p:txBody>
+      </p:sp>
+      <p:sp>
+        <p:nvSpPr>
+          <p:cNvPr id="13" name="TextBox 12"/>
+          <p:cNvSpPr txBox="1"/>
+          <p:nvPr/>
+        </p:nvSpPr>
+        <p:spPr>
+          <a:xfrm>
+            <a:off x="4937760" y="3915918"/>
+            <a:ext cx="6675119" cy="422910"/>
+          </a:xfrm>
+          <a:prstGeom prst="rect">
+            <a:avLst/>
+          </a:prstGeom>
+          <a:noFill/>
+        </p:spPr>
+        <p:txBody>
+          <a:bodyPr wrap="square" anchor="t" lIns="0" rIns="0" tIns="0" bIns="0">
+            <a:spAutoFit/>
+          </a:bodyPr>
+          <a:lstStyle/>
+          <a:p>
+            <a:pPr algn="l">
+              <a:lnSpc>
+                <a:spcPct val="132000"/>
+              </a:lnSpc>
+              <a:spcBef>
+                <a:spcPts val="0"/>
+              </a:spcBef>
+              <a:spcAft>
+                <a:spcPts val="0"/>
+              </a:spcAft>
+            </a:pPr>
+            <a:r>
+              <a:rPr sz="1150" b="0">
+                <a:solidFill>
+                  <a:srgbClr val="4A4A4A"/>
+                </a:solidFill>
+                <a:latin typeface="Pretendard"/>
+                <a:ea typeface="Pretendard"/>
+              </a:rPr>
+              <a:t>신규 파이프라인으로 미래를 준비합니다.</a:t>
+            </a:r>
+          </a:p>
+        </p:txBody>
+      </p:sp>
+      <p:sp>
+        <p:nvSpPr>
+          <p:cNvPr id="14" name="TextBox 13"/>
+          <p:cNvSpPr txBox="1"/>
+          <p:nvPr/>
+        </p:nvSpPr>
+        <p:spPr>
+          <a:xfrm>
+            <a:off x="4023360" y="4411980"/>
+            <a:ext cx="868680" cy="548640"/>
+          </a:xfrm>
+          <a:prstGeom prst="rect">
+            <a:avLst/>
+          </a:prstGeom>
+          <a:noFill/>
+        </p:spPr>
+        <p:txBody>
+          <a:bodyPr wrap="square" anchor="t" lIns="0" rIns="0" tIns="0" bIns="0">
+            <a:spAutoFit/>
+          </a:bodyPr>
+          <a:lstStyle/>
+          <a:p>
+            <a:pPr algn="l">
+              <a:lnSpc>
+                <a:spcPct val="115000"/>
+              </a:lnSpc>
+              <a:spcBef>
+                <a:spcPts val="0"/>
+              </a:spcBef>
+              <a:spcAft>
+                <a:spcPts val="0"/>
+              </a:spcAft>
+            </a:pPr>
+            <a:r>
+              <a:rPr sz="2100" b="1">
+                <a:solidFill>
+                  <a:srgbClr val="2E7D32"/>
+                </a:solidFill>
+                <a:latin typeface="Pretendard"/>
+                <a:ea typeface="Pretendard"/>
+              </a:rPr>
+              <a:t>03</a:t>
+            </a:r>
+          </a:p>
+        </p:txBody>
+      </p:sp>
+      <p:sp>
+        <p:nvSpPr>
+          <p:cNvPr id="15" name="TextBox 14"/>
+          <p:cNvSpPr txBox="1"/>
+          <p:nvPr/>
+        </p:nvSpPr>
+        <p:spPr>
+          <a:xfrm>
+            <a:off x="4937760" y="4411980"/>
+            <a:ext cx="6675119" cy="384048"/>
+          </a:xfrm>
+          <a:prstGeom prst="rect">
+            <a:avLst/>
+          </a:prstGeom>
+          <a:noFill/>
+        </p:spPr>
+        <p:txBody>
+          <a:bodyPr wrap="square" anchor="t" lIns="0" rIns="0" tIns="0" bIns="0">
+            <a:spAutoFit/>
+          </a:bodyPr>
+          <a:lstStyle/>
+          <a:p>
+            <a:pPr algn="l">
+              <a:lnSpc>
+                <a:spcPct val="115000"/>
+              </a:lnSpc>
+              <a:spcBef>
+                <a:spcPts val="0"/>
+              </a:spcBef>
+              <a:spcAft>
+                <a:spcPts val="0"/>
+              </a:spcAft>
+            </a:pPr>
+            <a:r>
+              <a:rPr sz="1400" b="1">
+                <a:solidFill>
+                  <a:srgbClr val="1A1A1A"/>
+                </a:solidFill>
+                <a:latin typeface="Pretendard"/>
+                <a:ea typeface="Pretendard"/>
+              </a:rPr>
+              <a:t>직판 강화</a:t>
+            </a:r>
+          </a:p>
+        </p:txBody>
+      </p:sp>
+      <p:sp>
+        <p:nvSpPr>
+          <p:cNvPr id="16" name="TextBox 15"/>
+          <p:cNvSpPr txBox="1"/>
+          <p:nvPr/>
+        </p:nvSpPr>
+        <p:spPr>
+          <a:xfrm>
+            <a:off x="4937760" y="4796028"/>
+            <a:ext cx="6675119" cy="422910"/>
+          </a:xfrm>
+          <a:prstGeom prst="rect">
+            <a:avLst/>
+          </a:prstGeom>
+          <a:noFill/>
+        </p:spPr>
+        <p:txBody>
+          <a:bodyPr wrap="square" anchor="t" lIns="0" rIns="0" tIns="0" bIns="0">
+            <a:spAutoFit/>
+          </a:bodyPr>
+          <a:lstStyle/>
+          <a:p>
+            <a:pPr algn="l">
+              <a:lnSpc>
+                <a:spcPct val="132000"/>
+              </a:lnSpc>
+              <a:spcBef>
+                <a:spcPts val="0"/>
+              </a:spcBef>
+              <a:spcAft>
+                <a:spcPts val="0"/>
+              </a:spcAft>
+            </a:pPr>
+            <a:r>
+              <a:rPr sz="1150" b="0">
+                <a:solidFill>
+                  <a:srgbClr val="4A4A4A"/>
+                </a:solidFill>
+                <a:latin typeface="Pretendard"/>
+                <a:ea typeface="Pretendard"/>
+              </a:rPr>
+              <a:t>직접판매로 수익성을 개선합니다.</a:t>
+            </a:r>
+          </a:p>
+        </p:txBody>
+      </p:sp>
+      <p:sp>
+        <p:nvSpPr>
+          <p:cNvPr id="17" name="TextBox 16"/>
+          <p:cNvSpPr txBox="1"/>
+          <p:nvPr/>
+        </p:nvSpPr>
+        <p:spPr>
+          <a:xfrm>
+            <a:off x="4023360" y="5292090"/>
+            <a:ext cx="868680" cy="548640"/>
+          </a:xfrm>
+          <a:prstGeom prst="rect">
+            <a:avLst/>
+          </a:prstGeom>
+          <a:noFill/>
+        </p:spPr>
+        <p:txBody>
+          <a:bodyPr wrap="square" anchor="t" lIns="0" rIns="0" tIns="0" bIns="0">
+            <a:spAutoFit/>
+          </a:bodyPr>
+          <a:lstStyle/>
+          <a:p>
+            <a:pPr algn="l">
+              <a:lnSpc>
+                <a:spcPct val="115000"/>
+              </a:lnSpc>
+              <a:spcBef>
+                <a:spcPts val="0"/>
+              </a:spcBef>
+              <a:spcAft>
+                <a:spcPts val="0"/>
+              </a:spcAft>
+            </a:pPr>
+            <a:r>
+              <a:rPr sz="2100" b="1">
+                <a:solidFill>
+                  <a:srgbClr val="2E7D32"/>
+                </a:solidFill>
+                <a:latin typeface="Pretendard"/>
+                <a:ea typeface="Pretendard"/>
+              </a:rPr>
+              <a:t>04</a:t>
+            </a:r>
+          </a:p>
+        </p:txBody>
+      </p:sp>
+      <p:sp>
+        <p:nvSpPr>
+          <p:cNvPr id="18" name="TextBox 17"/>
+          <p:cNvSpPr txBox="1"/>
+          <p:nvPr/>
+        </p:nvSpPr>
+        <p:spPr>
+          <a:xfrm>
+            <a:off x="4937760" y="5292090"/>
+            <a:ext cx="6675119" cy="384048"/>
+          </a:xfrm>
+          <a:prstGeom prst="rect">
+            <a:avLst/>
+          </a:prstGeom>
+          <a:noFill/>
+        </p:spPr>
+        <p:txBody>
+          <a:bodyPr wrap="square" anchor="t" lIns="0" rIns="0" tIns="0" bIns="0">
+            <a:spAutoFit/>
+          </a:bodyPr>
+          <a:lstStyle/>
+          <a:p>
+            <a:pPr algn="l">
+              <a:lnSpc>
+                <a:spcPct val="115000"/>
+              </a:lnSpc>
+              <a:spcBef>
+                <a:spcPts val="0"/>
+              </a:spcBef>
+              <a:spcAft>
+                <a:spcPts val="0"/>
+              </a:spcAft>
+            </a:pPr>
+            <a:r>
+              <a:rPr sz="1400" b="1">
+                <a:solidFill>
+                  <a:srgbClr val="1A1A1A"/>
+                </a:solidFill>
+                <a:latin typeface="Pretendard"/>
+                <a:ea typeface="Pretendard"/>
+              </a:rPr>
+              <a:t>글로벌 접근성</a:t>
+            </a:r>
+          </a:p>
+        </p:txBody>
+      </p:sp>
+      <p:sp>
+        <p:nvSpPr>
+          <p:cNvPr id="19" name="TextBox 18"/>
+          <p:cNvSpPr txBox="1"/>
+          <p:nvPr/>
+        </p:nvSpPr>
+        <p:spPr>
+          <a:xfrm>
+            <a:off x="4937760" y="5676138"/>
+            <a:ext cx="6675119" cy="422910"/>
+          </a:xfrm>
+          <a:prstGeom prst="rect">
+            <a:avLst/>
+          </a:prstGeom>
+          <a:noFill/>
+        </p:spPr>
+        <p:txBody>
+          <a:bodyPr wrap="square" anchor="t" lIns="0" rIns="0" tIns="0" bIns="0">
+            <a:spAutoFit/>
+          </a:bodyPr>
+          <a:lstStyle/>
+          <a:p>
+            <a:pPr algn="l">
+              <a:lnSpc>
+                <a:spcPct val="132000"/>
+              </a:lnSpc>
+              <a:spcBef>
+                <a:spcPts val="0"/>
+              </a:spcBef>
+              <a:spcAft>
+                <a:spcPts val="0"/>
+              </a:spcAft>
+            </a:pPr>
+            <a:r>
+              <a:rPr sz="1150" b="0">
+                <a:solidFill>
+                  <a:srgbClr val="4A4A4A"/>
+                </a:solidFill>
+                <a:latin typeface="Pretendard"/>
+                <a:ea typeface="Pretendard"/>
+              </a:rPr>
+              <a:t>세계 환자에게 직접 다가갑니다.</a:t>
+            </a:r>
+          </a:p>
+        </p:txBody>
+      </p:sp>
+    </p:spTree>
+  </p:cSld>
+  <p:clrMapOvr>
+    <a:masterClrMapping/>
+  </p:clrMapOvr>
+</p:sld>
+</file>
+
+<file path=ppt/slides/slide9.xml><?xml version="1.0" encoding="utf-8"?>
+<p:sld xmlns:a="http://schemas.openxmlformats.org/drawingml/2006/main" xmlns:p="http://schemas.openxmlformats.org/presentationml/2006/main" xmlns:r="http://schemas.openxmlformats.org/officeDocument/2006/relationships">
+  <p:cSld>
+    <p:bg>
+      <p:bgPr>
+        <a:solidFill>
+          <a:srgbClr val="FFFFFF"/>
+        </a:solidFill>
+        <a:effectLst/>
+      </p:bgPr>
+    </p:bg>
+    <p:spTree>
+      <p:nvGrpSpPr>
+        <p:cNvPr id="1" name=""/>
+        <p:cNvGrpSpPr/>
+        <p:nvPr/>
+      </p:nvGrpSpPr>
+      <p:grpSpPr/>
+      <p:sp>
+        <p:nvSpPr>
+          <p:cNvPr id="2" name="TextBox 1"/>
+          <p:cNvSpPr txBox="1"/>
+          <p:nvPr/>
+        </p:nvSpPr>
+        <p:spPr>
+          <a:xfrm>
+            <a:off x="566928" y="402336"/>
+            <a:ext cx="8686800" cy="292608"/>
+          </a:xfrm>
+          <a:prstGeom prst="rect">
+            <a:avLst/>
+          </a:prstGeom>
+          <a:noFill/>
+        </p:spPr>
+        <p:txBody>
+          <a:bodyPr wrap="square" anchor="t" lIns="0" rIns="0" tIns="0" bIns="0">
+            <a:spAutoFit/>
+          </a:bodyPr>
+          <a:lstStyle/>
+          <a:p>
+            <a:pPr algn="l">
+              <a:lnSpc>
+                <a:spcPct val="115000"/>
+              </a:lnSpc>
+              <a:spcBef>
+                <a:spcPts val="0"/>
+              </a:spcBef>
+              <a:spcAft>
+                <a:spcPts val="0"/>
+              </a:spcAft>
+            </a:pPr>
+            <a:r>
+              <a:rPr sz="1100" b="1" spc="120">
+                <a:solidFill>
+                  <a:srgbClr val="2E7D32"/>
+                </a:solidFill>
+                <a:latin typeface="Pretendard"/>
+                <a:ea typeface="Pretendard"/>
+              </a:rPr>
+              <a:t>04 · 성장 로드맵</a:t>
+            </a:r>
+          </a:p>
+        </p:txBody>
+      </p:sp>
+      <p:sp>
+        <p:nvSpPr>
+          <p:cNvPr id="3" name="TextBox 2"/>
+          <p:cNvSpPr txBox="1"/>
+          <p:nvPr/>
+        </p:nvSpPr>
+        <p:spPr>
+          <a:xfrm>
+            <a:off x="566928" y="841248"/>
+            <a:ext cx="11064240" cy="914400"/>
+          </a:xfrm>
+          <a:prstGeom prst="rect">
+            <a:avLst/>
+          </a:prstGeom>
+          <a:noFill/>
+        </p:spPr>
+        <p:txBody>
+          <a:bodyPr wrap="square" anchor="t" lIns="0" rIns="0" tIns="0" bIns="0">
+            <a:spAutoFit/>
+          </a:bodyPr>
+          <a:lstStyle/>
+          <a:p>
+            <a:pPr algn="l">
+              <a:lnSpc>
+                <a:spcPct val="115000"/>
+              </a:lnSpc>
+              <a:spcBef>
+                <a:spcPts val="0"/>
+              </a:spcBef>
+              <a:spcAft>
+                <a:spcPts val="0"/>
+              </a:spcAft>
+            </a:pPr>
+            <a:r>
+              <a:rPr sz="2500" b="1">
+                <a:solidFill>
+                  <a:srgbClr val="1A1A1A"/>
+                </a:solidFill>
+                <a:latin typeface="Pretendard"/>
+                <a:ea typeface="Pretendard"/>
+              </a:rPr>
+              <a:t>성장 로드맵</a:t>
+            </a:r>
+          </a:p>
+        </p:txBody>
+      </p:sp>
+      <p:sp>
+        <p:nvSpPr>
+          <p:cNvPr id="4" name="TextBox 3"/>
+          <p:cNvSpPr txBox="1"/>
+          <p:nvPr/>
+        </p:nvSpPr>
+        <p:spPr>
+          <a:xfrm>
+            <a:off x="566928" y="1627632"/>
+            <a:ext cx="11064240" cy="548640"/>
+          </a:xfrm>
+          <a:prstGeom prst="rect">
+            <a:avLst/>
+          </a:prstGeom>
+          <a:noFill/>
+        </p:spPr>
+        <p:txBody>
+          <a:bodyPr wrap="square" anchor="t" lIns="0" rIns="0" tIns="0" bIns="0">
+            <a:spAutoFit/>
+          </a:bodyPr>
+          <a:lstStyle/>
+          <a:p>
+            <a:pPr algn="l">
+              <a:lnSpc>
+                <a:spcPct val="115000"/>
+              </a:lnSpc>
+              <a:spcBef>
+                <a:spcPts val="0"/>
+              </a:spcBef>
+              <a:spcAft>
+                <a:spcPts val="0"/>
+              </a:spcAft>
+            </a:pPr>
+            <a:r>
+              <a:rPr sz="1400" b="0">
+                <a:solidFill>
+                  <a:srgbClr val="4A4A4A"/>
+                </a:solidFill>
+                <a:latin typeface="Pretendard"/>
+                <a:ea typeface="Pretendard"/>
+              </a:rPr>
+              <a:t>단계적 성장 전개 (일정은 브랜드 테마 예시)</a:t>
+            </a:r>
+          </a:p>
+        </p:txBody>
+      </p:sp>
+      <p:sp>
+        <p:nvSpPr>
+          <p:cNvPr id="5" name="Rectangle 4"/>
+          <p:cNvSpPr/>
+          <p:nvPr/>
+        </p:nvSpPr>
+        <p:spPr>
+          <a:xfrm>
+            <a:off x="566928" y="2194560"/>
+            <a:ext cx="1005840" cy="41148"/>
+          </a:xfrm>
+          <a:prstGeom prst="rect">
+            <a:avLst/>
+          </a:prstGeom>
+          <a:solidFill>
+            <a:srgbClr val="50B848"/>
+          </a:solidFill>
+          <a:ln>
+            <a:noFill/>
+          </a:ln>
+          <a:effectLst/>
+        </p:spPr>
+        <p:style>
+          <a:lnRef idx="1">
+            <a:schemeClr val="accent1"/>
+          </a:lnRef>
+          <a:fillRef idx="3">
+            <a:schemeClr val="accent1"/>
+          </a:fillRef>
+          <a:effectRef idx="2">
+            <a:schemeClr val="accent1"/>
+          </a:effectRef>
+          <a:fontRef idx="minor">
+            <a:schemeClr val="lt1"/>
+          </a:fontRef>
+        </p:style>
+        <p:txBody>
+          <a:bodyPr rtlCol="0" anchor="ctr"/>
+          <a:lstStyle/>
+          <a:p>
+            <a:pPr algn="ctr"/>
+          </a:p>
+        </p:txBody>
+      </p:sp>
+      <p:sp>
+        <p:nvSpPr>
+          <p:cNvPr id="6" name="Rectangle 5"/>
+          <p:cNvSpPr/>
+          <p:nvPr/>
+        </p:nvSpPr>
+        <p:spPr>
+          <a:xfrm>
+            <a:off x="1572768" y="2211019"/>
+            <a:ext cx="10058400" cy="10972"/>
+          </a:xfrm>
+          <a:prstGeom prst="rect">
+            <a:avLst/>
+          </a:prstGeom>
+          <a:solidFill>
+            <a:srgbClr val="E1E3E8"/>
+          </a:solidFill>
+          <a:ln>
+            <a:noFill/>
+          </a:ln>
+          <a:effectLst/>
+        </p:spPr>
+        <p:style>
+          <a:lnRef idx="1">
+            <a:schemeClr val="accent1"/>
+          </a:lnRef>
+          <a:fillRef idx="3">
+            <a:schemeClr val="accent1"/>
+          </a:fillRef>
+          <a:effectRef idx="2">
+            <a:schemeClr val="accent1"/>
+          </a:effectRef>
+          <a:fontRef idx="minor">
+            <a:schemeClr val="lt1"/>
+          </a:fontRef>
+        </p:style>
+        <p:txBody>
+          <a:bodyPr rtlCol="0" anchor="ctr"/>
+          <a:lstStyle/>
+          <a:p>
+            <a:pPr algn="ctr"/>
+          </a:p>
+        </p:txBody>
+      </p:sp>
+      <p:pic>
+        <p:nvPicPr>
+          <p:cNvPr id="7" name="Picture 6" descr="roadmap.png"/>
+          <p:cNvPicPr>
+            <a:picLocks noChangeAspect="1"/>
+          </p:cNvPicPr>
+          <p:nvPr/>
+        </p:nvPicPr>
+        <p:blipFill>
+          <a:blip r:embed="rId2"/>
+          <a:stretch>
+            <a:fillRect/>
+          </a:stretch>
+        </p:blipFill>
+        <p:spPr>
+          <a:xfrm>
+            <a:off x="1415933" y="2468880"/>
+            <a:ext cx="9366228" cy="3657600"/>
+          </a:xfrm>
+          <a:prstGeom prst="rect">
+            <a:avLst/>
+          </a:prstGeom>
+        </p:spPr>
+      </p:pic>
     </p:spTree>
   </p:cSld>
   <p:clrMapOvr>

</xml_diff>